<commit_message>
Configuratie Figurenboek uitgebreid met 14 OKO indicatoren en kruisverbanden (Toegevoegde regels zijn geelgemarkeerd). Dubbele sheet uit rapportage template gehaald.
</commit_message>
<xml_diff>
--- a/oko/template figurenboek oko.pptx
+++ b/oko/template figurenboek oko.pptx
@@ -144,7 +144,7 @@
 <file path=ppt/revisionInfo.xml><?xml version="1.0" encoding="utf-8"?>
 <p1510:revInfo xmlns:a="http://schemas.openxmlformats.org/drawingml/2006/main" xmlns:r="http://schemas.openxmlformats.org/officeDocument/2006/relationships" xmlns:p1510="http://schemas.microsoft.com/office/powerpoint/2015/10/main">
   <p1510:revLst>
-    <p1510:client id="{FCBE63D5-02DD-424C-AE6D-321977844E5F}" v="104" dt="2026-01-07T13:00:55.112"/>
+    <p1510:client id="{FCBE63D5-02DD-424C-AE6D-321977844E5F}" v="106" dt="2026-01-15T14:40:19.893"/>
   </p1510:revLst>
 </p1510:revInfo>
 </file>
@@ -154,12 +154,12 @@
   <pc:docChgLst>
     <pc:chgData name="Vermeulen - van Gent, Sander" userId="e08259fd-81d2-4a86-9b20-28ba02d67a18" providerId="ADAL" clId="{CD1B3BBE-56CC-4974-BC5E-9FCD75B07556}"/>
     <pc:docChg chg="undo custSel addSld delSld modSld delMainMaster modMainMaster">
-      <pc:chgData name="Vermeulen - van Gent, Sander" userId="e08259fd-81d2-4a86-9b20-28ba02d67a18" providerId="ADAL" clId="{CD1B3BBE-56CC-4974-BC5E-9FCD75B07556}" dt="2026-01-07T13:00:55.112" v="3242" actId="962"/>
+      <pc:chgData name="Vermeulen - van Gent, Sander" userId="e08259fd-81d2-4a86-9b20-28ba02d67a18" providerId="ADAL" clId="{CD1B3BBE-56CC-4974-BC5E-9FCD75B07556}" dt="2026-01-15T14:41:06.531" v="3257" actId="1076"/>
       <pc:docMkLst>
         <pc:docMk/>
       </pc:docMkLst>
       <pc:sldMasterChg chg="delSp mod addSldLayout delSldLayout modSldLayout">
-        <pc:chgData name="Vermeulen - van Gent, Sander" userId="e08259fd-81d2-4a86-9b20-28ba02d67a18" providerId="ADAL" clId="{CD1B3BBE-56CC-4974-BC5E-9FCD75B07556}" dt="2026-01-07T13:00:55.112" v="3242" actId="962"/>
+        <pc:chgData name="Vermeulen - van Gent, Sander" userId="e08259fd-81d2-4a86-9b20-28ba02d67a18" providerId="ADAL" clId="{CD1B3BBE-56CC-4974-BC5E-9FCD75B07556}" dt="2026-01-15T14:41:06.531" v="3257" actId="1076"/>
         <pc:sldMasterMkLst>
           <pc:docMk/>
           <pc:sldMasterMk cId="582609979" sldId="2147483648"/>
@@ -171,15 +171,6 @@
             <pc:sldMasterMk cId="582609979" sldId="2147483648"/>
             <pc:sldLayoutMk cId="2036413586" sldId="2147483653"/>
           </pc:sldLayoutMkLst>
-          <pc:spChg chg="add del mod">
-            <ac:chgData name="Vermeulen - van Gent, Sander" userId="e08259fd-81d2-4a86-9b20-28ba02d67a18" providerId="ADAL" clId="{CD1B3BBE-56CC-4974-BC5E-9FCD75B07556}" dt="2026-01-07T13:00:15.032" v="3220" actId="478"/>
-            <ac:spMkLst>
-              <pc:docMk/>
-              <pc:sldMasterMk cId="582609979" sldId="2147483648"/>
-              <pc:sldLayoutMk cId="2036413586" sldId="2147483653"/>
-              <ac:spMk id="2" creationId="{13C24EA0-4787-80B5-74A3-EC535F6B0EC1}"/>
-            </ac:spMkLst>
-          </pc:spChg>
           <pc:spChg chg="add mod">
             <ac:chgData name="Vermeulen - van Gent, Sander" userId="e08259fd-81d2-4a86-9b20-28ba02d67a18" providerId="ADAL" clId="{CD1B3BBE-56CC-4974-BC5E-9FCD75B07556}" dt="2025-12-22T12:12:36.689" v="2896" actId="1076"/>
             <ac:spMkLst>
@@ -187,15 +178,6 @@
               <pc:sldMasterMk cId="582609979" sldId="2147483648"/>
               <pc:sldLayoutMk cId="2036413586" sldId="2147483653"/>
               <ac:spMk id="3" creationId="{2E304EC1-1C7E-0547-A8B9-C344F217EDE9}"/>
-            </ac:spMkLst>
-          </pc:spChg>
-          <pc:spChg chg="add del">
-            <ac:chgData name="Vermeulen - van Gent, Sander" userId="e08259fd-81d2-4a86-9b20-28ba02d67a18" providerId="ADAL" clId="{CD1B3BBE-56CC-4974-BC5E-9FCD75B07556}" dt="2026-01-07T13:00:23.977" v="3221" actId="11529"/>
-            <ac:spMkLst>
-              <pc:docMk/>
-              <pc:sldMasterMk cId="582609979" sldId="2147483648"/>
-              <pc:sldLayoutMk cId="2036413586" sldId="2147483653"/>
-              <ac:spMk id="4" creationId="{D5E132C3-36DC-E8CE-7813-0D4889D790E6}"/>
             </ac:spMkLst>
           </pc:spChg>
           <pc:spChg chg="add mod">
@@ -215,15 +197,6 @@
             <pc:sldMasterMk cId="582609979" sldId="2147483648"/>
             <pc:sldLayoutMk cId="1902983804" sldId="2147483712"/>
           </pc:sldLayoutMkLst>
-          <pc:spChg chg="add del mod">
-            <ac:chgData name="Vermeulen - van Gent, Sander" userId="e08259fd-81d2-4a86-9b20-28ba02d67a18" providerId="ADAL" clId="{CD1B3BBE-56CC-4974-BC5E-9FCD75B07556}" dt="2026-01-07T08:44:34.922" v="3191" actId="478"/>
-            <ac:spMkLst>
-              <pc:docMk/>
-              <pc:sldMasterMk cId="582609979" sldId="2147483648"/>
-              <pc:sldLayoutMk cId="1902983804" sldId="2147483712"/>
-              <ac:spMk id="3" creationId="{49816605-5308-CDCA-2306-3F14CA8441D1}"/>
-            </ac:spMkLst>
-          </pc:spChg>
           <pc:spChg chg="add mod">
             <ac:chgData name="Vermeulen - van Gent, Sander" userId="e08259fd-81d2-4a86-9b20-28ba02d67a18" providerId="ADAL" clId="{CD1B3BBE-56CC-4974-BC5E-9FCD75B07556}" dt="2026-01-07T08:44:35.146" v="3192"/>
             <ac:spMkLst>
@@ -330,15 +303,6 @@
             <pc:sldMasterMk cId="582609979" sldId="2147483648"/>
             <pc:sldLayoutMk cId="3350624530" sldId="2147483715"/>
           </pc:sldLayoutMkLst>
-          <pc:spChg chg="add del mod">
-            <ac:chgData name="Vermeulen - van Gent, Sander" userId="e08259fd-81d2-4a86-9b20-28ba02d67a18" providerId="ADAL" clId="{CD1B3BBE-56CC-4974-BC5E-9FCD75B07556}" dt="2026-01-07T08:44:55.148" v="3193" actId="478"/>
-            <ac:spMkLst>
-              <pc:docMk/>
-              <pc:sldMasterMk cId="582609979" sldId="2147483648"/>
-              <pc:sldLayoutMk cId="3350624530" sldId="2147483715"/>
-              <ac:spMk id="3" creationId="{7FFED495-DF98-5DCE-B2C3-12D5B63E28A6}"/>
-            </ac:spMkLst>
-          </pc:spChg>
           <pc:spChg chg="add mod">
             <ac:chgData name="Vermeulen - van Gent, Sander" userId="e08259fd-81d2-4a86-9b20-28ba02d67a18" providerId="ADAL" clId="{CD1B3BBE-56CC-4974-BC5E-9FCD75B07556}" dt="2026-01-07T08:44:55.310" v="3194"/>
             <ac:spMkLst>
@@ -401,15 +365,6 @@
             <pc:sldMasterMk cId="582609979" sldId="2147483648"/>
             <pc:sldLayoutMk cId="3253258482" sldId="2147483716"/>
           </pc:sldLayoutMkLst>
-          <pc:spChg chg="add del mod">
-            <ac:chgData name="Vermeulen - van Gent, Sander" userId="e08259fd-81d2-4a86-9b20-28ba02d67a18" providerId="ADAL" clId="{CD1B3BBE-56CC-4974-BC5E-9FCD75B07556}" dt="2026-01-07T08:44:58.357" v="3195" actId="478"/>
-            <ac:spMkLst>
-              <pc:docMk/>
-              <pc:sldMasterMk cId="582609979" sldId="2147483648"/>
-              <pc:sldLayoutMk cId="3253258482" sldId="2147483716"/>
-              <ac:spMk id="2" creationId="{C0418B1A-ADF1-DA84-8B38-B27F5459991C}"/>
-            </ac:spMkLst>
-          </pc:spChg>
           <pc:spChg chg="add mod">
             <ac:chgData name="Vermeulen - van Gent, Sander" userId="e08259fd-81d2-4a86-9b20-28ba02d67a18" providerId="ADAL" clId="{CD1B3BBE-56CC-4974-BC5E-9FCD75B07556}" dt="2026-01-07T08:44:58.578" v="3196"/>
             <ac:spMkLst>
@@ -472,15 +427,6 @@
             <pc:sldMasterMk cId="582609979" sldId="2147483648"/>
             <pc:sldLayoutMk cId="830588291" sldId="2147483717"/>
           </pc:sldLayoutMkLst>
-          <pc:spChg chg="add del mod">
-            <ac:chgData name="Vermeulen - van Gent, Sander" userId="e08259fd-81d2-4a86-9b20-28ba02d67a18" providerId="ADAL" clId="{CD1B3BBE-56CC-4974-BC5E-9FCD75B07556}" dt="2026-01-07T08:46:31.992" v="3213" actId="478"/>
-            <ac:spMkLst>
-              <pc:docMk/>
-              <pc:sldMasterMk cId="582609979" sldId="2147483648"/>
-              <pc:sldLayoutMk cId="830588291" sldId="2147483717"/>
-              <ac:spMk id="2" creationId="{A26CEB15-B43B-D904-3869-FA48B6EEA64B}"/>
-            </ac:spMkLst>
-          </pc:spChg>
           <pc:spChg chg="add mod">
             <ac:chgData name="Vermeulen - van Gent, Sander" userId="e08259fd-81d2-4a86-9b20-28ba02d67a18" providerId="ADAL" clId="{CD1B3BBE-56CC-4974-BC5E-9FCD75B07556}" dt="2026-01-07T08:46:32.246" v="3214"/>
             <ac:spMkLst>
@@ -543,15 +489,6 @@
             <pc:sldMasterMk cId="582609979" sldId="2147483648"/>
             <pc:sldLayoutMk cId="2787105181" sldId="2147483718"/>
           </pc:sldLayoutMkLst>
-          <pc:spChg chg="add del mod">
-            <ac:chgData name="Vermeulen - van Gent, Sander" userId="e08259fd-81d2-4a86-9b20-28ba02d67a18" providerId="ADAL" clId="{CD1B3BBE-56CC-4974-BC5E-9FCD75B07556}" dt="2026-01-07T08:46:34.942" v="3215" actId="478"/>
-            <ac:spMkLst>
-              <pc:docMk/>
-              <pc:sldMasterMk cId="582609979" sldId="2147483648"/>
-              <pc:sldLayoutMk cId="2787105181" sldId="2147483718"/>
-              <ac:spMk id="2" creationId="{99C6EB58-2952-62F6-C2EB-FA62E0259852}"/>
-            </ac:spMkLst>
-          </pc:spChg>
           <pc:spChg chg="add mod">
             <ac:chgData name="Vermeulen - van Gent, Sander" userId="e08259fd-81d2-4a86-9b20-28ba02d67a18" providerId="ADAL" clId="{CD1B3BBE-56CC-4974-BC5E-9FCD75B07556}" dt="2026-01-07T08:46:35.157" v="3216"/>
             <ac:spMkLst>
@@ -614,15 +551,6 @@
             <pc:sldMasterMk cId="582609979" sldId="2147483648"/>
             <pc:sldLayoutMk cId="1634006264" sldId="2147483719"/>
           </pc:sldLayoutMkLst>
-          <pc:spChg chg="add del mod">
-            <ac:chgData name="Vermeulen - van Gent, Sander" userId="e08259fd-81d2-4a86-9b20-28ba02d67a18" providerId="ADAL" clId="{CD1B3BBE-56CC-4974-BC5E-9FCD75B07556}" dt="2026-01-07T08:46:37.520" v="3217" actId="478"/>
-            <ac:spMkLst>
-              <pc:docMk/>
-              <pc:sldMasterMk cId="582609979" sldId="2147483648"/>
-              <pc:sldLayoutMk cId="1634006264" sldId="2147483719"/>
-              <ac:spMk id="2" creationId="{0C143FA4-DFC1-1DE0-CE64-15CB5F4AC9EC}"/>
-            </ac:spMkLst>
-          </pc:spChg>
           <pc:spChg chg="add mod">
             <ac:chgData name="Vermeulen - van Gent, Sander" userId="e08259fd-81d2-4a86-9b20-28ba02d67a18" providerId="ADAL" clId="{CD1B3BBE-56CC-4974-BC5E-9FCD75B07556}" dt="2026-01-07T08:46:37.733" v="3218"/>
             <ac:spMkLst>
@@ -685,96 +613,6 @@
             <pc:sldMasterMk cId="582609979" sldId="2147483648"/>
             <pc:sldLayoutMk cId="3062801688" sldId="2147483720"/>
           </pc:sldLayoutMkLst>
-          <pc:spChg chg="add del mod">
-            <ac:chgData name="Vermeulen - van Gent, Sander" userId="e08259fd-81d2-4a86-9b20-28ba02d67a18" providerId="ADAL" clId="{CD1B3BBE-56CC-4974-BC5E-9FCD75B07556}" dt="2026-01-07T08:42:33.475" v="3150" actId="478"/>
-            <ac:spMkLst>
-              <pc:docMk/>
-              <pc:sldMasterMk cId="582609979" sldId="2147483648"/>
-              <pc:sldLayoutMk cId="3062801688" sldId="2147483720"/>
-              <ac:spMk id="2" creationId="{14291275-E2F5-315C-4B2B-14600857624A}"/>
-            </ac:spMkLst>
-          </pc:spChg>
-          <pc:spChg chg="add del mod">
-            <ac:chgData name="Vermeulen - van Gent, Sander" userId="e08259fd-81d2-4a86-9b20-28ba02d67a18" providerId="ADAL" clId="{CD1B3BBE-56CC-4974-BC5E-9FCD75B07556}" dt="2026-01-07T08:42:28.818" v="3149" actId="478"/>
-            <ac:spMkLst>
-              <pc:docMk/>
-              <pc:sldMasterMk cId="582609979" sldId="2147483648"/>
-              <pc:sldLayoutMk cId="3062801688" sldId="2147483720"/>
-              <ac:spMk id="3" creationId="{8C2A4EB1-9221-6583-DD0B-891BBE82166A}"/>
-            </ac:spMkLst>
-          </pc:spChg>
-          <pc:spChg chg="add mod">
-            <ac:chgData name="Vermeulen - van Gent, Sander" userId="e08259fd-81d2-4a86-9b20-28ba02d67a18" providerId="ADAL" clId="{CD1B3BBE-56CC-4974-BC5E-9FCD75B07556}" dt="2026-01-07T08:41:34.136" v="3147"/>
-            <ac:spMkLst>
-              <pc:docMk/>
-              <pc:sldMasterMk cId="582609979" sldId="2147483648"/>
-              <pc:sldLayoutMk cId="3062801688" sldId="2147483720"/>
-              <ac:spMk id="6" creationId="{A64DC78A-18DC-633C-077E-38A469E53A27}"/>
-            </ac:spMkLst>
-          </pc:spChg>
-          <pc:spChg chg="add mod">
-            <ac:chgData name="Vermeulen - van Gent, Sander" userId="e08259fd-81d2-4a86-9b20-28ba02d67a18" providerId="ADAL" clId="{CD1B3BBE-56CC-4974-BC5E-9FCD75B07556}" dt="2026-01-07T08:41:34.136" v="3147"/>
-            <ac:spMkLst>
-              <pc:docMk/>
-              <pc:sldMasterMk cId="582609979" sldId="2147483648"/>
-              <pc:sldLayoutMk cId="3062801688" sldId="2147483720"/>
-              <ac:spMk id="8" creationId="{EBB6FC60-12A9-23C5-86CE-04C5CF309A66}"/>
-            </ac:spMkLst>
-          </pc:spChg>
-          <pc:spChg chg="add mod">
-            <ac:chgData name="Vermeulen - van Gent, Sander" userId="e08259fd-81d2-4a86-9b20-28ba02d67a18" providerId="ADAL" clId="{CD1B3BBE-56CC-4974-BC5E-9FCD75B07556}" dt="2026-01-07T08:42:12.723" v="3148"/>
-            <ac:spMkLst>
-              <pc:docMk/>
-              <pc:sldMasterMk cId="582609979" sldId="2147483648"/>
-              <pc:sldLayoutMk cId="3062801688" sldId="2147483720"/>
-              <ac:spMk id="11" creationId="{7817E749-B626-6FBC-01A3-00E11CDB90F7}"/>
-            </ac:spMkLst>
-          </pc:spChg>
-          <pc:spChg chg="add mod">
-            <ac:chgData name="Vermeulen - van Gent, Sander" userId="e08259fd-81d2-4a86-9b20-28ba02d67a18" providerId="ADAL" clId="{CD1B3BBE-56CC-4974-BC5E-9FCD75B07556}" dt="2026-01-07T08:42:12.723" v="3148"/>
-            <ac:spMkLst>
-              <pc:docMk/>
-              <pc:sldMasterMk cId="582609979" sldId="2147483648"/>
-              <pc:sldLayoutMk cId="3062801688" sldId="2147483720"/>
-              <ac:spMk id="12" creationId="{EEE098D9-5AD5-42D1-203D-6CD1EBC6CEBD}"/>
-            </ac:spMkLst>
-          </pc:spChg>
-          <pc:spChg chg="add del mod ord">
-            <ac:chgData name="Vermeulen - van Gent, Sander" userId="e08259fd-81d2-4a86-9b20-28ba02d67a18" providerId="ADAL" clId="{CD1B3BBE-56CC-4974-BC5E-9FCD75B07556}" dt="2026-01-07T08:45:49.775" v="3197" actId="478"/>
-            <ac:spMkLst>
-              <pc:docMk/>
-              <pc:sldMasterMk cId="582609979" sldId="2147483648"/>
-              <pc:sldLayoutMk cId="3062801688" sldId="2147483720"/>
-              <ac:spMk id="15" creationId="{303B6071-B517-F0E3-2C4F-AC4128D847FC}"/>
-            </ac:spMkLst>
-          </pc:spChg>
-          <pc:spChg chg="add del mod">
-            <ac:chgData name="Vermeulen - van Gent, Sander" userId="e08259fd-81d2-4a86-9b20-28ba02d67a18" providerId="ADAL" clId="{CD1B3BBE-56CC-4974-BC5E-9FCD75B07556}" dt="2026-01-07T08:45:49.775" v="3197" actId="478"/>
-            <ac:spMkLst>
-              <pc:docMk/>
-              <pc:sldMasterMk cId="582609979" sldId="2147483648"/>
-              <pc:sldLayoutMk cId="3062801688" sldId="2147483720"/>
-              <ac:spMk id="16" creationId="{C4E94BFF-B92A-69CB-994A-B902D36974E6}"/>
-            </ac:spMkLst>
-          </pc:spChg>
-          <pc:spChg chg="add del mod">
-            <ac:chgData name="Vermeulen - van Gent, Sander" userId="e08259fd-81d2-4a86-9b20-28ba02d67a18" providerId="ADAL" clId="{CD1B3BBE-56CC-4974-BC5E-9FCD75B07556}" dt="2026-01-07T08:45:49.775" v="3197" actId="478"/>
-            <ac:spMkLst>
-              <pc:docMk/>
-              <pc:sldMasterMk cId="582609979" sldId="2147483648"/>
-              <pc:sldLayoutMk cId="3062801688" sldId="2147483720"/>
-              <ac:spMk id="17" creationId="{EAA70A1C-F6F5-C693-CC3C-FF6FA4B4E0C7}"/>
-            </ac:spMkLst>
-          </pc:spChg>
-          <pc:spChg chg="add del mod">
-            <ac:chgData name="Vermeulen - van Gent, Sander" userId="e08259fd-81d2-4a86-9b20-28ba02d67a18" providerId="ADAL" clId="{CD1B3BBE-56CC-4974-BC5E-9FCD75B07556}" dt="2026-01-07T08:45:49.775" v="3197" actId="478"/>
-            <ac:spMkLst>
-              <pc:docMk/>
-              <pc:sldMasterMk cId="582609979" sldId="2147483648"/>
-              <pc:sldLayoutMk cId="3062801688" sldId="2147483720"/>
-              <ac:spMk id="18" creationId="{CEA741DC-5035-FA4F-DA60-1260882BE1CC}"/>
-            </ac:spMkLst>
-          </pc:spChg>
           <pc:spChg chg="add mod">
             <ac:chgData name="Vermeulen - van Gent, Sander" userId="e08259fd-81d2-4a86-9b20-28ba02d67a18" providerId="ADAL" clId="{CD1B3BBE-56CC-4974-BC5E-9FCD75B07556}" dt="2026-01-07T08:46:02.160" v="3200" actId="962"/>
             <ac:spMkLst>
@@ -793,78 +631,6 @@
               <ac:spMk id="20" creationId="{EED19F67-71F6-8279-301C-45C1477E4829}"/>
             </ac:spMkLst>
           </pc:spChg>
-          <pc:spChg chg="add mod">
-            <ac:chgData name="Vermeulen - van Gent, Sander" userId="e08259fd-81d2-4a86-9b20-28ba02d67a18" providerId="ADAL" clId="{CD1B3BBE-56CC-4974-BC5E-9FCD75B07556}" dt="2026-01-07T08:46:04.305" v="3202" actId="571"/>
-            <ac:spMkLst>
-              <pc:docMk/>
-              <pc:sldMasterMk cId="582609979" sldId="2147483648"/>
-              <pc:sldLayoutMk cId="3062801688" sldId="2147483720"/>
-              <ac:spMk id="21" creationId="{5761DBA8-A50F-1030-E43A-879560E9BB72}"/>
-            </ac:spMkLst>
-          </pc:spChg>
-          <pc:spChg chg="add mod">
-            <ac:chgData name="Vermeulen - van Gent, Sander" userId="e08259fd-81d2-4a86-9b20-28ba02d67a18" providerId="ADAL" clId="{CD1B3BBE-56CC-4974-BC5E-9FCD75B07556}" dt="2026-01-07T08:46:04.305" v="3202" actId="571"/>
-            <ac:spMkLst>
-              <pc:docMk/>
-              <pc:sldMasterMk cId="582609979" sldId="2147483648"/>
-              <pc:sldLayoutMk cId="3062801688" sldId="2147483720"/>
-              <ac:spMk id="22" creationId="{D89C8D33-261C-837F-E21B-476A3271884F}"/>
-            </ac:spMkLst>
-          </pc:spChg>
-          <pc:cxnChg chg="add mod">
-            <ac:chgData name="Vermeulen - van Gent, Sander" userId="e08259fd-81d2-4a86-9b20-28ba02d67a18" providerId="ADAL" clId="{CD1B3BBE-56CC-4974-BC5E-9FCD75B07556}" dt="2026-01-07T08:41:34.136" v="3147"/>
-            <ac:cxnSpMkLst>
-              <pc:docMk/>
-              <pc:sldMasterMk cId="582609979" sldId="2147483648"/>
-              <pc:sldLayoutMk cId="3062801688" sldId="2147483720"/>
-              <ac:cxnSpMk id="4" creationId="{881FF28A-8AED-E947-B2C4-93A6BD1C0921}"/>
-            </ac:cxnSpMkLst>
-          </pc:cxnChg>
-          <pc:cxnChg chg="add mod">
-            <ac:chgData name="Vermeulen - van Gent, Sander" userId="e08259fd-81d2-4a86-9b20-28ba02d67a18" providerId="ADAL" clId="{CD1B3BBE-56CC-4974-BC5E-9FCD75B07556}" dt="2026-01-07T08:41:34.136" v="3147"/>
-            <ac:cxnSpMkLst>
-              <pc:docMk/>
-              <pc:sldMasterMk cId="582609979" sldId="2147483648"/>
-              <pc:sldLayoutMk cId="3062801688" sldId="2147483720"/>
-              <ac:cxnSpMk id="5" creationId="{904034E7-3539-A48A-4DA3-B29FADB0439C}"/>
-            </ac:cxnSpMkLst>
-          </pc:cxnChg>
-          <pc:cxnChg chg="add mod">
-            <ac:chgData name="Vermeulen - van Gent, Sander" userId="e08259fd-81d2-4a86-9b20-28ba02d67a18" providerId="ADAL" clId="{CD1B3BBE-56CC-4974-BC5E-9FCD75B07556}" dt="2026-01-07T08:42:12.723" v="3148"/>
-            <ac:cxnSpMkLst>
-              <pc:docMk/>
-              <pc:sldMasterMk cId="582609979" sldId="2147483648"/>
-              <pc:sldLayoutMk cId="3062801688" sldId="2147483720"/>
-              <ac:cxnSpMk id="9" creationId="{743B50D7-6851-A688-FEF2-CA86A06EA663}"/>
-            </ac:cxnSpMkLst>
-          </pc:cxnChg>
-          <pc:cxnChg chg="add mod">
-            <ac:chgData name="Vermeulen - van Gent, Sander" userId="e08259fd-81d2-4a86-9b20-28ba02d67a18" providerId="ADAL" clId="{CD1B3BBE-56CC-4974-BC5E-9FCD75B07556}" dt="2026-01-07T08:42:12.723" v="3148"/>
-            <ac:cxnSpMkLst>
-              <pc:docMk/>
-              <pc:sldMasterMk cId="582609979" sldId="2147483648"/>
-              <pc:sldLayoutMk cId="3062801688" sldId="2147483720"/>
-              <ac:cxnSpMk id="10" creationId="{80544F1D-D097-C74A-143B-A85BB43E74AE}"/>
-            </ac:cxnSpMkLst>
-          </pc:cxnChg>
-          <pc:cxnChg chg="add del mod">
-            <ac:chgData name="Vermeulen - van Gent, Sander" userId="e08259fd-81d2-4a86-9b20-28ba02d67a18" providerId="ADAL" clId="{CD1B3BBE-56CC-4974-BC5E-9FCD75B07556}" dt="2026-01-07T08:45:49.775" v="3197" actId="478"/>
-            <ac:cxnSpMkLst>
-              <pc:docMk/>
-              <pc:sldMasterMk cId="582609979" sldId="2147483648"/>
-              <pc:sldLayoutMk cId="3062801688" sldId="2147483720"/>
-              <ac:cxnSpMk id="13" creationId="{41A7815D-315E-A205-B812-F256D4155555}"/>
-            </ac:cxnSpMkLst>
-          </pc:cxnChg>
-          <pc:cxnChg chg="add del mod">
-            <ac:chgData name="Vermeulen - van Gent, Sander" userId="e08259fd-81d2-4a86-9b20-28ba02d67a18" providerId="ADAL" clId="{CD1B3BBE-56CC-4974-BC5E-9FCD75B07556}" dt="2026-01-07T08:43:40.432" v="3179" actId="478"/>
-            <ac:cxnSpMkLst>
-              <pc:docMk/>
-              <pc:sldMasterMk cId="582609979" sldId="2147483648"/>
-              <pc:sldLayoutMk cId="3062801688" sldId="2147483720"/>
-              <ac:cxnSpMk id="14" creationId="{AD4A9995-53B5-1B9B-4806-E0A35C265AD5}"/>
-            </ac:cxnSpMkLst>
-          </pc:cxnChg>
         </pc:sldLayoutChg>
         <pc:sldLayoutChg chg="addSp delSp modSp add mod modTransition">
           <pc:chgData name="Vermeulen - van Gent, Sander" userId="e08259fd-81d2-4a86-9b20-28ba02d67a18" providerId="ADAL" clId="{CD1B3BBE-56CC-4974-BC5E-9FCD75B07556}" dt="2026-01-07T08:46:13.457" v="3206"/>
@@ -880,24 +646,6 @@
               <pc:sldMasterMk cId="582609979" sldId="2147483648"/>
               <pc:sldLayoutMk cId="2778263677" sldId="2147483721"/>
               <ac:spMk id="2" creationId="{F64AA85D-C735-4864-540C-91D5497BC380}"/>
-            </ac:spMkLst>
-          </pc:spChg>
-          <pc:spChg chg="add del mod">
-            <ac:chgData name="Vermeulen - van Gent, Sander" userId="e08259fd-81d2-4a86-9b20-28ba02d67a18" providerId="ADAL" clId="{CD1B3BBE-56CC-4974-BC5E-9FCD75B07556}" dt="2026-01-07T08:46:13.062" v="3205" actId="478"/>
-            <ac:spMkLst>
-              <pc:docMk/>
-              <pc:sldMasterMk cId="582609979" sldId="2147483648"/>
-              <pc:sldLayoutMk cId="2778263677" sldId="2147483721"/>
-              <ac:spMk id="3" creationId="{D68B9398-87C8-C4D3-4E50-08DC2E7E354F}"/>
-            </ac:spMkLst>
-          </pc:spChg>
-          <pc:spChg chg="add del mod">
-            <ac:chgData name="Vermeulen - van Gent, Sander" userId="e08259fd-81d2-4a86-9b20-28ba02d67a18" providerId="ADAL" clId="{CD1B3BBE-56CC-4974-BC5E-9FCD75B07556}" dt="2026-01-07T08:46:13.062" v="3205" actId="478"/>
-            <ac:spMkLst>
-              <pc:docMk/>
-              <pc:sldMasterMk cId="582609979" sldId="2147483648"/>
-              <pc:sldLayoutMk cId="2778263677" sldId="2147483721"/>
-              <ac:spMk id="4" creationId="{46FD2D60-5977-C19C-214D-1D5A0AF94583}"/>
             </ac:spMkLst>
           </pc:spChg>
           <pc:spChg chg="add mod">
@@ -917,15 +665,6 @@
             <pc:sldMasterMk cId="582609979" sldId="2147483648"/>
             <pc:sldLayoutMk cId="1801002620" sldId="2147483722"/>
           </pc:sldLayoutMkLst>
-          <pc:spChg chg="add del mod">
-            <ac:chgData name="Vermeulen - van Gent, Sander" userId="e08259fd-81d2-4a86-9b20-28ba02d67a18" providerId="ADAL" clId="{CD1B3BBE-56CC-4974-BC5E-9FCD75B07556}" dt="2026-01-07T08:46:09.738" v="3203" actId="478"/>
-            <ac:spMkLst>
-              <pc:docMk/>
-              <pc:sldMasterMk cId="582609979" sldId="2147483648"/>
-              <pc:sldLayoutMk cId="1801002620" sldId="2147483722"/>
-              <ac:spMk id="2" creationId="{2939AB82-88CB-71DE-79B9-9AEE7910F9D8}"/>
-            </ac:spMkLst>
-          </pc:spChg>
           <pc:spChg chg="add mod">
             <ac:chgData name="Vermeulen - van Gent, Sander" userId="e08259fd-81d2-4a86-9b20-28ba02d67a18" providerId="ADAL" clId="{CD1B3BBE-56CC-4974-BC5E-9FCD75B07556}" dt="2026-01-07T08:46:09.970" v="3204"/>
             <ac:spMkLst>
@@ -933,15 +672,6 @@
               <pc:sldMasterMk cId="582609979" sldId="2147483648"/>
               <pc:sldLayoutMk cId="1801002620" sldId="2147483722"/>
               <ac:spMk id="3" creationId="{5F193AA4-09A3-CB31-87EE-2F190A925E48}"/>
-            </ac:spMkLst>
-          </pc:spChg>
-          <pc:spChg chg="add del mod">
-            <ac:chgData name="Vermeulen - van Gent, Sander" userId="e08259fd-81d2-4a86-9b20-28ba02d67a18" providerId="ADAL" clId="{CD1B3BBE-56CC-4974-BC5E-9FCD75B07556}" dt="2026-01-07T08:46:09.738" v="3203" actId="478"/>
-            <ac:spMkLst>
-              <pc:docMk/>
-              <pc:sldMasterMk cId="582609979" sldId="2147483648"/>
-              <pc:sldLayoutMk cId="1801002620" sldId="2147483722"/>
-              <ac:spMk id="4" creationId="{6A044E49-B62D-8BF0-9E24-B9C61412FE8A}"/>
             </ac:spMkLst>
           </pc:spChg>
           <pc:spChg chg="add mod">
@@ -970,24 +700,6 @@
               <ac:spMk id="2" creationId="{B506A536-0E45-CA74-5422-F8A3CD3C9A7D}"/>
             </ac:spMkLst>
           </pc:spChg>
-          <pc:spChg chg="add del mod">
-            <ac:chgData name="Vermeulen - van Gent, Sander" userId="e08259fd-81d2-4a86-9b20-28ba02d67a18" providerId="ADAL" clId="{CD1B3BBE-56CC-4974-BC5E-9FCD75B07556}" dt="2026-01-07T08:46:16.605" v="3207" actId="478"/>
-            <ac:spMkLst>
-              <pc:docMk/>
-              <pc:sldMasterMk cId="582609979" sldId="2147483648"/>
-              <pc:sldLayoutMk cId="835085721" sldId="2147483723"/>
-              <ac:spMk id="3" creationId="{0EC362ED-DB5E-933C-C2C0-B08D273E99C1}"/>
-            </ac:spMkLst>
-          </pc:spChg>
-          <pc:spChg chg="add del mod">
-            <ac:chgData name="Vermeulen - van Gent, Sander" userId="e08259fd-81d2-4a86-9b20-28ba02d67a18" providerId="ADAL" clId="{CD1B3BBE-56CC-4974-BC5E-9FCD75B07556}" dt="2026-01-07T08:46:16.605" v="3207" actId="478"/>
-            <ac:spMkLst>
-              <pc:docMk/>
-              <pc:sldMasterMk cId="582609979" sldId="2147483648"/>
-              <pc:sldLayoutMk cId="835085721" sldId="2147483723"/>
-              <ac:spMk id="4" creationId="{D33D3A27-874B-FBE9-25B2-2B47EBA3CEDD}"/>
-            </ac:spMkLst>
-          </pc:spChg>
           <pc:spChg chg="add mod">
             <ac:chgData name="Vermeulen - van Gent, Sander" userId="e08259fd-81d2-4a86-9b20-28ba02d67a18" providerId="ADAL" clId="{CD1B3BBE-56CC-4974-BC5E-9FCD75B07556}" dt="2026-01-07T08:46:16.807" v="3208"/>
             <ac:spMkLst>
@@ -1012,24 +724,6 @@
               <pc:sldMasterMk cId="582609979" sldId="2147483648"/>
               <pc:sldLayoutMk cId="2017985558" sldId="2147483724"/>
               <ac:spMk id="2" creationId="{FD346B7F-1470-FD49-0A16-6E569F38EF23}"/>
-            </ac:spMkLst>
-          </pc:spChg>
-          <pc:spChg chg="add del mod">
-            <ac:chgData name="Vermeulen - van Gent, Sander" userId="e08259fd-81d2-4a86-9b20-28ba02d67a18" providerId="ADAL" clId="{CD1B3BBE-56CC-4974-BC5E-9FCD75B07556}" dt="2026-01-07T08:46:19.479" v="3209" actId="478"/>
-            <ac:spMkLst>
-              <pc:docMk/>
-              <pc:sldMasterMk cId="582609979" sldId="2147483648"/>
-              <pc:sldLayoutMk cId="2017985558" sldId="2147483724"/>
-              <ac:spMk id="3" creationId="{33739E64-8E67-2455-17F6-4B27700D09D8}"/>
-            </ac:spMkLst>
-          </pc:spChg>
-          <pc:spChg chg="add del mod">
-            <ac:chgData name="Vermeulen - van Gent, Sander" userId="e08259fd-81d2-4a86-9b20-28ba02d67a18" providerId="ADAL" clId="{CD1B3BBE-56CC-4974-BC5E-9FCD75B07556}" dt="2026-01-07T08:46:19.479" v="3209" actId="478"/>
-            <ac:spMkLst>
-              <pc:docMk/>
-              <pc:sldMasterMk cId="582609979" sldId="2147483648"/>
-              <pc:sldLayoutMk cId="2017985558" sldId="2147483724"/>
-              <ac:spMk id="4" creationId="{013B46A4-BC38-846B-9C56-7C2BDA51DC9C}"/>
             </ac:spMkLst>
           </pc:spChg>
           <pc:spChg chg="add mod">
@@ -1058,24 +752,6 @@
               <ac:spMk id="2" creationId="{F94CB744-EBE0-46F5-AA5C-1D7E395C52ED}"/>
             </ac:spMkLst>
           </pc:spChg>
-          <pc:spChg chg="add del mod">
-            <ac:chgData name="Vermeulen - van Gent, Sander" userId="e08259fd-81d2-4a86-9b20-28ba02d67a18" providerId="ADAL" clId="{CD1B3BBE-56CC-4974-BC5E-9FCD75B07556}" dt="2026-01-07T08:46:23.525" v="3211" actId="478"/>
-            <ac:spMkLst>
-              <pc:docMk/>
-              <pc:sldMasterMk cId="582609979" sldId="2147483648"/>
-              <pc:sldLayoutMk cId="4251520629" sldId="2147483725"/>
-              <ac:spMk id="3" creationId="{D2B2C666-6DF2-961D-9352-D0AED5B18EBA}"/>
-            </ac:spMkLst>
-          </pc:spChg>
-          <pc:spChg chg="add del mod">
-            <ac:chgData name="Vermeulen - van Gent, Sander" userId="e08259fd-81d2-4a86-9b20-28ba02d67a18" providerId="ADAL" clId="{CD1B3BBE-56CC-4974-BC5E-9FCD75B07556}" dt="2026-01-07T08:46:23.525" v="3211" actId="478"/>
-            <ac:spMkLst>
-              <pc:docMk/>
-              <pc:sldMasterMk cId="582609979" sldId="2147483648"/>
-              <pc:sldLayoutMk cId="4251520629" sldId="2147483725"/>
-              <ac:spMk id="4" creationId="{EE3E73AB-6C46-5B1A-D080-B9D7846A483B}"/>
-            </ac:spMkLst>
-          </pc:spChg>
           <pc:spChg chg="add mod">
             <ac:chgData name="Vermeulen - van Gent, Sander" userId="e08259fd-81d2-4a86-9b20-28ba02d67a18" providerId="ADAL" clId="{CD1B3BBE-56CC-4974-BC5E-9FCD75B07556}" dt="2026-01-07T08:46:23.732" v="3212"/>
             <ac:spMkLst>
@@ -1083,6 +759,50 @@
               <pc:sldMasterMk cId="582609979" sldId="2147483648"/>
               <pc:sldLayoutMk cId="4251520629" sldId="2147483725"/>
               <ac:spMk id="5" creationId="{F7A597E2-FD7D-1171-F122-D7BDBA2F3D1C}"/>
+            </ac:spMkLst>
+          </pc:spChg>
+        </pc:sldLayoutChg>
+        <pc:sldLayoutChg chg="addSp delSp modSp add mod modTransition">
+          <pc:chgData name="Vermeulen - van Gent, Sander" userId="e08259fd-81d2-4a86-9b20-28ba02d67a18" providerId="ADAL" clId="{CD1B3BBE-56CC-4974-BC5E-9FCD75B07556}" dt="2026-01-15T14:41:06.531" v="3257" actId="1076"/>
+          <pc:sldLayoutMkLst>
+            <pc:docMk/>
+            <pc:sldMasterMk cId="582609979" sldId="2147483648"/>
+            <pc:sldLayoutMk cId="3674646998" sldId="2147483726"/>
+          </pc:sldLayoutMkLst>
+          <pc:spChg chg="add del">
+            <ac:chgData name="Vermeulen - van Gent, Sander" userId="e08259fd-81d2-4a86-9b20-28ba02d67a18" providerId="ADAL" clId="{CD1B3BBE-56CC-4974-BC5E-9FCD75B07556}" dt="2026-01-15T14:40:19.893" v="3249" actId="11529"/>
+            <ac:spMkLst>
+              <pc:docMk/>
+              <pc:sldMasterMk cId="582609979" sldId="2147483648"/>
+              <pc:sldLayoutMk cId="3674646998" sldId="2147483726"/>
+              <ac:spMk id="2" creationId="{067FF25F-F034-917F-2144-B434E3FDA8E1}"/>
+            </ac:spMkLst>
+          </pc:spChg>
+          <pc:spChg chg="mod">
+            <ac:chgData name="Vermeulen - van Gent, Sander" userId="e08259fd-81d2-4a86-9b20-28ba02d67a18" providerId="ADAL" clId="{CD1B3BBE-56CC-4974-BC5E-9FCD75B07556}" dt="2026-01-15T14:41:06.531" v="3257" actId="1076"/>
+            <ac:spMkLst>
+              <pc:docMk/>
+              <pc:sldMasterMk cId="582609979" sldId="2147483648"/>
+              <pc:sldLayoutMk cId="3674646998" sldId="2147483726"/>
+              <ac:spMk id="3" creationId="{5F193AA4-09A3-CB31-87EE-2F190A925E48}"/>
+            </ac:spMkLst>
+          </pc:spChg>
+          <pc:spChg chg="add del mod">
+            <ac:chgData name="Vermeulen - van Gent, Sander" userId="e08259fd-81d2-4a86-9b20-28ba02d67a18" providerId="ADAL" clId="{CD1B3BBE-56CC-4974-BC5E-9FCD75B07556}" dt="2026-01-15T14:40:28.099" v="3252" actId="478"/>
+            <ac:spMkLst>
+              <pc:docMk/>
+              <pc:sldMasterMk cId="582609979" sldId="2147483648"/>
+              <pc:sldLayoutMk cId="3674646998" sldId="2147483726"/>
+              <ac:spMk id="4" creationId="{2A9A4EAB-E28A-BC10-1AC1-FF14C806BDA0}"/>
+            </ac:spMkLst>
+          </pc:spChg>
+          <pc:spChg chg="del">
+            <ac:chgData name="Vermeulen - van Gent, Sander" userId="e08259fd-81d2-4a86-9b20-28ba02d67a18" providerId="ADAL" clId="{CD1B3BBE-56CC-4974-BC5E-9FCD75B07556}" dt="2026-01-15T14:39:44.164" v="3244" actId="478"/>
+            <ac:spMkLst>
+              <pc:docMk/>
+              <pc:sldMasterMk cId="582609979" sldId="2147483648"/>
+              <pc:sldLayoutMk cId="3674646998" sldId="2147483726"/>
+              <ac:spMk id="5" creationId="{17069FB9-1CAC-9FEB-25C3-FB8E804B1CA5}"/>
             </ac:spMkLst>
           </pc:spChg>
         </pc:sldLayoutChg>
@@ -1186,7 +906,7 @@
           <a:p>
             <a:fld id="{BBEDBBAB-6028-4680-9556-A8238B314949}" type="datetimeFigureOut">
               <a:rPr lang="nl-NL" smtClean="0"/>
-              <a:t>7-1-2026</a:t>
+              <a:t>15-1-2026</a:t>
             </a:fld>
             <a:endParaRPr lang="nl-NL"/>
           </a:p>
@@ -1362,7 +1082,7 @@
           </a:lstStyle>
           <a:p>
             <a:fld id="{37F81271-B6F7-4A7E-8F6C-1E1DF4AA2733}" type="datetimeFigureOut">
-              <a:t>7-1-2026</a:t>
+              <a:t>15-1-2026</a:t>
             </a:fld>
             <a:endParaRPr lang="nl-NL"/>
           </a:p>
@@ -1990,6 +1710,373 @@
 
 <file path=ppt/slideLayouts/slideLayout10.xml><?xml version="1.0" encoding="utf-8"?>
 <p:sldLayout xmlns:a="http://schemas.openxmlformats.org/drawingml/2006/main" xmlns:r="http://schemas.openxmlformats.org/officeDocument/2006/relationships" xmlns:p="http://schemas.openxmlformats.org/presentationml/2006/main" preserve="1" userDrawn="1">
+  <p:cSld name="School">
+    <p:spTree>
+      <p:nvGrpSpPr>
+        <p:cNvPr id="1" name=""/>
+        <p:cNvGrpSpPr/>
+        <p:nvPr/>
+      </p:nvGrpSpPr>
+      <p:grpSpPr>
+        <a:xfrm>
+          <a:off x="0" y="0"/>
+          <a:ext cx="0" cy="0"/>
+          <a:chOff x="0" y="0"/>
+          <a:chExt cx="0" cy="0"/>
+        </a:xfrm>
+      </p:grpSpPr>
+      <p:sp>
+        <p:nvSpPr>
+          <p:cNvPr id="7" name="Titelblok">
+            <a:extLst>
+              <a:ext uri="{FF2B5EF4-FFF2-40B4-BE49-F238E27FC236}">
+                <a16:creationId xmlns:a16="http://schemas.microsoft.com/office/drawing/2014/main" id="{A53C9265-3CEF-A2C1-7746-C8CDC77B0852}"/>
+              </a:ext>
+            </a:extLst>
+          </p:cNvPr>
+          <p:cNvSpPr/>
+          <p:nvPr userDrawn="1"/>
+        </p:nvSpPr>
+        <p:spPr>
+          <a:xfrm>
+            <a:off x="0" y="0"/>
+            <a:ext cx="10295595" cy="1066801"/>
+          </a:xfrm>
+          <a:custGeom>
+            <a:avLst/>
+            <a:gdLst>
+              <a:gd name="connsiteX0" fmla="*/ 0 w 10295595"/>
+              <a:gd name="connsiteY0" fmla="*/ 0 h 1066800"/>
+              <a:gd name="connsiteX1" fmla="*/ 10295595 w 10295595"/>
+              <a:gd name="connsiteY1" fmla="*/ 0 h 1066800"/>
+              <a:gd name="connsiteX2" fmla="*/ 10295595 w 10295595"/>
+              <a:gd name="connsiteY2" fmla="*/ 1066800 h 1066800"/>
+              <a:gd name="connsiteX3" fmla="*/ 0 w 10295595"/>
+              <a:gd name="connsiteY3" fmla="*/ 1066800 h 1066800"/>
+              <a:gd name="connsiteX4" fmla="*/ 0 w 10295595"/>
+              <a:gd name="connsiteY4" fmla="*/ 0 h 1066800"/>
+              <a:gd name="connsiteX0" fmla="*/ 0 w 10295595"/>
+              <a:gd name="connsiteY0" fmla="*/ 0 h 1066800"/>
+              <a:gd name="connsiteX1" fmla="*/ 10295595 w 10295595"/>
+              <a:gd name="connsiteY1" fmla="*/ 0 h 1066800"/>
+              <a:gd name="connsiteX2" fmla="*/ 9737543 w 10295595"/>
+              <a:gd name="connsiteY2" fmla="*/ 1066800 h 1066800"/>
+              <a:gd name="connsiteX3" fmla="*/ 0 w 10295595"/>
+              <a:gd name="connsiteY3" fmla="*/ 1066800 h 1066800"/>
+              <a:gd name="connsiteX4" fmla="*/ 0 w 10295595"/>
+              <a:gd name="connsiteY4" fmla="*/ 0 h 1066800"/>
+              <a:gd name="connsiteX0" fmla="*/ 0 w 10295595"/>
+              <a:gd name="connsiteY0" fmla="*/ 0 h 1066800"/>
+              <a:gd name="connsiteX1" fmla="*/ 10295595 w 10295595"/>
+              <a:gd name="connsiteY1" fmla="*/ 0 h 1066800"/>
+              <a:gd name="connsiteX2" fmla="*/ 9710649 w 10295595"/>
+              <a:gd name="connsiteY2" fmla="*/ 1060077 h 1066800"/>
+              <a:gd name="connsiteX3" fmla="*/ 0 w 10295595"/>
+              <a:gd name="connsiteY3" fmla="*/ 1066800 h 1066800"/>
+              <a:gd name="connsiteX4" fmla="*/ 0 w 10295595"/>
+              <a:gd name="connsiteY4" fmla="*/ 0 h 1066800"/>
+              <a:gd name="connsiteX0" fmla="*/ 0 w 10295595"/>
+              <a:gd name="connsiteY0" fmla="*/ 0 h 1066801"/>
+              <a:gd name="connsiteX1" fmla="*/ 10295595 w 10295595"/>
+              <a:gd name="connsiteY1" fmla="*/ 0 h 1066801"/>
+              <a:gd name="connsiteX2" fmla="*/ 9710649 w 10295595"/>
+              <a:gd name="connsiteY2" fmla="*/ 1066801 h 1066801"/>
+              <a:gd name="connsiteX3" fmla="*/ 0 w 10295595"/>
+              <a:gd name="connsiteY3" fmla="*/ 1066800 h 1066801"/>
+              <a:gd name="connsiteX4" fmla="*/ 0 w 10295595"/>
+              <a:gd name="connsiteY4" fmla="*/ 0 h 1066801"/>
+            </a:gdLst>
+            <a:ahLst/>
+            <a:cxnLst>
+              <a:cxn ang="0">
+                <a:pos x="connsiteX0" y="connsiteY0"/>
+              </a:cxn>
+              <a:cxn ang="0">
+                <a:pos x="connsiteX1" y="connsiteY1"/>
+              </a:cxn>
+              <a:cxn ang="0">
+                <a:pos x="connsiteX2" y="connsiteY2"/>
+              </a:cxn>
+              <a:cxn ang="0">
+                <a:pos x="connsiteX3" y="connsiteY3"/>
+              </a:cxn>
+              <a:cxn ang="0">
+                <a:pos x="connsiteX4" y="connsiteY4"/>
+              </a:cxn>
+            </a:cxnLst>
+            <a:rect l="l" t="t" r="r" b="b"/>
+            <a:pathLst>
+              <a:path w="10295595" h="1066801">
+                <a:moveTo>
+                  <a:pt x="0" y="0"/>
+                </a:moveTo>
+                <a:lnTo>
+                  <a:pt x="10295595" y="0"/>
+                </a:lnTo>
+                <a:lnTo>
+                  <a:pt x="9710649" y="1066801"/>
+                </a:lnTo>
+                <a:lnTo>
+                  <a:pt x="0" y="1066800"/>
+                </a:lnTo>
+                <a:lnTo>
+                  <a:pt x="0" y="0"/>
+                </a:lnTo>
+                <a:close/>
+              </a:path>
+            </a:pathLst>
+          </a:custGeom>
+          <a:solidFill>
+            <a:schemeClr val="accent4"/>
+          </a:solidFill>
+          <a:ln>
+            <a:noFill/>
+          </a:ln>
+        </p:spPr>
+        <p:style>
+          <a:lnRef idx="0">
+            <a:scrgbClr r="0" g="0" b="0"/>
+          </a:lnRef>
+          <a:fillRef idx="0">
+            <a:scrgbClr r="0" g="0" b="0"/>
+          </a:fillRef>
+          <a:effectRef idx="0">
+            <a:scrgbClr r="0" g="0" b="0"/>
+          </a:effectRef>
+          <a:fontRef idx="minor">
+            <a:schemeClr val="lt1"/>
+          </a:fontRef>
+        </p:style>
+        <p:txBody>
+          <a:bodyPr rtlCol="0" anchor="ctr"/>
+          <a:lstStyle/>
+          <a:p>
+            <a:pPr marL="0" indent="270272" algn="l"/>
+            <a:r>
+              <a:rPr lang="nl-NL" sz="2400" b="1" noProof="0" dirty="0">
+                <a:latin typeface="Century Gothic" panose="020B0502020202020204" pitchFamily="34" charset="0"/>
+              </a:rPr>
+              <a:t>School</a:t>
+            </a:r>
+            <a:endParaRPr lang="nl-NL" sz="1800" b="1" noProof="0" dirty="0">
+              <a:latin typeface="Century Gothic" panose="020B0502020202020204" pitchFamily="34" charset="0"/>
+            </a:endParaRPr>
+          </a:p>
+        </p:txBody>
+      </p:sp>
+      <p:cxnSp>
+        <p:nvCxnSpPr>
+          <p:cNvPr id="3" name="Rechte verbindingslijn 1">
+            <a:extLst>
+              <a:ext uri="{FF2B5EF4-FFF2-40B4-BE49-F238E27FC236}">
+                <a16:creationId xmlns:a16="http://schemas.microsoft.com/office/drawing/2014/main" id="{9AF48131-3415-6F18-82EA-A7896B2FF722}"/>
+              </a:ext>
+            </a:extLst>
+          </p:cNvPr>
+          <p:cNvCxnSpPr>
+            <a:cxnSpLocks/>
+          </p:cNvCxnSpPr>
+          <p:nvPr userDrawn="1"/>
+        </p:nvCxnSpPr>
+        <p:spPr>
+          <a:xfrm flipV="1">
+            <a:off x="4140175" y="1519200"/>
+            <a:ext cx="0" cy="4881600"/>
+          </a:xfrm>
+          <a:prstGeom prst="line">
+            <a:avLst/>
+          </a:prstGeom>
+          <a:ln w="12700">
+            <a:solidFill>
+              <a:schemeClr val="tx2">
+                <a:lumMod val="20000"/>
+                <a:lumOff val="80000"/>
+              </a:schemeClr>
+            </a:solidFill>
+          </a:ln>
+        </p:spPr>
+        <p:style>
+          <a:lnRef idx="1">
+            <a:schemeClr val="accent1"/>
+          </a:lnRef>
+          <a:fillRef idx="0">
+            <a:schemeClr val="accent1"/>
+          </a:fillRef>
+          <a:effectRef idx="0">
+            <a:schemeClr val="accent1"/>
+          </a:effectRef>
+          <a:fontRef idx="minor">
+            <a:schemeClr val="tx1"/>
+          </a:fontRef>
+        </p:style>
+      </p:cxnSp>
+      <p:sp>
+        <p:nvSpPr>
+          <p:cNvPr id="4" name="Grafiek 4">
+            <a:extLst>
+              <a:ext uri="{FF2B5EF4-FFF2-40B4-BE49-F238E27FC236}">
+                <a16:creationId xmlns:a16="http://schemas.microsoft.com/office/drawing/2014/main" id="{310E4352-31FF-44EB-5021-279E162058B9}"/>
+              </a:ext>
+            </a:extLst>
+          </p:cNvPr>
+          <p:cNvSpPr>
+            <a:spLocks noGrp="1"/>
+          </p:cNvSpPr>
+          <p:nvPr>
+            <p:ph type="chart" sz="quarter" idx="21"/>
+          </p:nvPr>
+        </p:nvSpPr>
+        <p:spPr>
+          <a:xfrm>
+            <a:off x="4366163" y="4204800"/>
+            <a:ext cx="5400000" cy="2160000"/>
+          </a:xfrm>
+          <a:prstGeom prst="rect">
+            <a:avLst/>
+          </a:prstGeom>
+        </p:spPr>
+        <p:txBody>
+          <a:bodyPr/>
+          <a:lstStyle>
+            <a:lvl1pPr marL="0" indent="0">
+              <a:buNone/>
+              <a:defRPr sz="3200"/>
+            </a:lvl1pPr>
+          </a:lstStyle>
+          <a:p>
+            <a:endParaRPr lang="nl-NL" dirty="0"/>
+          </a:p>
+        </p:txBody>
+      </p:sp>
+      <p:sp>
+        <p:nvSpPr>
+          <p:cNvPr id="5" name="Grafiek 3">
+            <a:extLst>
+              <a:ext uri="{FF2B5EF4-FFF2-40B4-BE49-F238E27FC236}">
+                <a16:creationId xmlns:a16="http://schemas.microsoft.com/office/drawing/2014/main" id="{549FA444-6519-F015-40E7-530F58844B81}"/>
+              </a:ext>
+            </a:extLst>
+          </p:cNvPr>
+          <p:cNvSpPr>
+            <a:spLocks noGrp="1"/>
+          </p:cNvSpPr>
+          <p:nvPr>
+            <p:ph type="chart" sz="quarter" idx="17"/>
+          </p:nvPr>
+        </p:nvSpPr>
+        <p:spPr>
+          <a:xfrm>
+            <a:off x="4366161" y="1519199"/>
+            <a:ext cx="5400000" cy="2160000"/>
+          </a:xfrm>
+          <a:prstGeom prst="rect">
+            <a:avLst/>
+          </a:prstGeom>
+        </p:spPr>
+        <p:txBody>
+          <a:bodyPr/>
+          <a:lstStyle>
+            <a:lvl1pPr marL="0" indent="0">
+              <a:buNone/>
+              <a:defRPr sz="3200"/>
+            </a:lvl1pPr>
+          </a:lstStyle>
+          <a:p>
+            <a:endParaRPr lang="nl-NL"/>
+          </a:p>
+        </p:txBody>
+      </p:sp>
+      <p:sp>
+        <p:nvSpPr>
+          <p:cNvPr id="6" name="Grafiek 2">
+            <a:extLst>
+              <a:ext uri="{FF2B5EF4-FFF2-40B4-BE49-F238E27FC236}">
+                <a16:creationId xmlns:a16="http://schemas.microsoft.com/office/drawing/2014/main" id="{F67D3483-9559-7D5C-8A22-30732942E8F9}"/>
+              </a:ext>
+            </a:extLst>
+          </p:cNvPr>
+          <p:cNvSpPr>
+            <a:spLocks noGrp="1"/>
+          </p:cNvSpPr>
+          <p:nvPr>
+            <p:ph type="chart" sz="quarter" idx="22"/>
+          </p:nvPr>
+        </p:nvSpPr>
+        <p:spPr>
+          <a:xfrm>
+            <a:off x="454514" y="4204800"/>
+            <a:ext cx="3456000" cy="2160000"/>
+          </a:xfrm>
+          <a:prstGeom prst="rect">
+            <a:avLst/>
+          </a:prstGeom>
+        </p:spPr>
+        <p:txBody>
+          <a:bodyPr/>
+          <a:lstStyle>
+            <a:lvl1pPr marL="0" indent="0">
+              <a:buNone/>
+              <a:defRPr sz="3200"/>
+            </a:lvl1pPr>
+          </a:lstStyle>
+          <a:p>
+            <a:endParaRPr lang="nl-NL" dirty="0"/>
+          </a:p>
+        </p:txBody>
+      </p:sp>
+      <p:sp>
+        <p:nvSpPr>
+          <p:cNvPr id="8" name="Grafiek 1">
+            <a:extLst>
+              <a:ext uri="{FF2B5EF4-FFF2-40B4-BE49-F238E27FC236}">
+                <a16:creationId xmlns:a16="http://schemas.microsoft.com/office/drawing/2014/main" id="{970EE836-F25C-DF4F-5C39-4E6A87FBE76D}"/>
+              </a:ext>
+            </a:extLst>
+          </p:cNvPr>
+          <p:cNvSpPr>
+            <a:spLocks noGrp="1"/>
+          </p:cNvSpPr>
+          <p:nvPr>
+            <p:ph type="chart" sz="quarter" idx="23"/>
+          </p:nvPr>
+        </p:nvSpPr>
+        <p:spPr>
+          <a:xfrm>
+            <a:off x="454514" y="1519199"/>
+            <a:ext cx="3456000" cy="2160000"/>
+          </a:xfrm>
+          <a:prstGeom prst="rect">
+            <a:avLst/>
+          </a:prstGeom>
+        </p:spPr>
+        <p:txBody>
+          <a:bodyPr/>
+          <a:lstStyle>
+            <a:lvl1pPr marL="0" indent="0">
+              <a:buNone/>
+              <a:defRPr sz="3200"/>
+            </a:lvl1pPr>
+          </a:lstStyle>
+          <a:p>
+            <a:endParaRPr lang="nl-NL" dirty="0"/>
+          </a:p>
+        </p:txBody>
+      </p:sp>
+    </p:spTree>
+    <p:extLst>
+      <p:ext uri="{BB962C8B-B14F-4D97-AF65-F5344CB8AC3E}">
+        <p14:creationId xmlns:p14="http://schemas.microsoft.com/office/powerpoint/2010/main" val="830588291"/>
+      </p:ext>
+    </p:extLst>
+  </p:cSld>
+  <p:clrMapOvr>
+    <a:masterClrMapping/>
+  </p:clrMapOvr>
+</p:sldLayout>
+</file>
+
+<file path=ppt/slideLayouts/slideLayout11.xml><?xml version="1.0" encoding="utf-8"?>
+<p:sldLayout xmlns:a="http://schemas.openxmlformats.org/drawingml/2006/main" xmlns:r="http://schemas.openxmlformats.org/officeDocument/2006/relationships" xmlns:p="http://schemas.openxmlformats.org/presentationml/2006/main" preserve="1" userDrawn="1">
   <p:cSld name="School 2">
     <p:spTree>
       <p:nvGrpSpPr>
@@ -2233,7 +2320,7 @@
 </p:sldLayout>
 </file>
 
-<file path=ppt/slideLayouts/slideLayout11.xml><?xml version="1.0" encoding="utf-8"?>
+<file path=ppt/slideLayouts/slideLayout12.xml><?xml version="1.0" encoding="utf-8"?>
 <p:sldLayout xmlns:a="http://schemas.openxmlformats.org/drawingml/2006/main" xmlns:r="http://schemas.openxmlformats.org/officeDocument/2006/relationships" xmlns:p="http://schemas.openxmlformats.org/presentationml/2006/main" preserve="1" userDrawn="1">
   <p:cSld name="Leeftijdsgenoten">
     <p:spTree>
@@ -2600,7 +2687,7 @@
 </p:sldLayout>
 </file>
 
-<file path=ppt/slideLayouts/slideLayout12.xml><?xml version="1.0" encoding="utf-8"?>
+<file path=ppt/slideLayouts/slideLayout13.xml><?xml version="1.0" encoding="utf-8"?>
 <p:sldLayout xmlns:a="http://schemas.openxmlformats.org/drawingml/2006/main" xmlns:r="http://schemas.openxmlformats.org/officeDocument/2006/relationships" xmlns:p="http://schemas.openxmlformats.org/presentationml/2006/main" preserve="1" userDrawn="1">
   <p:cSld name="Leeftijdsgenoten 2">
     <p:spTree>
@@ -2845,7 +2932,7 @@
 </p:sldLayout>
 </file>
 
-<file path=ppt/slideLayouts/slideLayout13.xml><?xml version="1.0" encoding="utf-8"?>
+<file path=ppt/slideLayouts/slideLayout14.xml><?xml version="1.0" encoding="utf-8"?>
 <p:sldLayout xmlns:a="http://schemas.openxmlformats.org/drawingml/2006/main" xmlns:r="http://schemas.openxmlformats.org/officeDocument/2006/relationships" xmlns:p="http://schemas.openxmlformats.org/presentationml/2006/main" preserve="1" userDrawn="1">
   <p:cSld name="Vrije tijd">
     <p:spTree>
@@ -3212,7 +3299,7 @@
 </p:sldLayout>
 </file>
 
-<file path=ppt/slideLayouts/slideLayout14.xml><?xml version="1.0" encoding="utf-8"?>
+<file path=ppt/slideLayouts/slideLayout15.xml><?xml version="1.0" encoding="utf-8"?>
 <p:sldLayout xmlns:a="http://schemas.openxmlformats.org/drawingml/2006/main" xmlns:r="http://schemas.openxmlformats.org/officeDocument/2006/relationships" xmlns:p="http://schemas.openxmlformats.org/presentationml/2006/main" preserve="1" userDrawn="1">
   <p:cSld name="Vrije tijd 2">
     <p:spTree>
@@ -4919,6 +5006,215 @@
 
 <file path=ppt/slideLayouts/slideLayout7.xml><?xml version="1.0" encoding="utf-8"?>
 <p:sldLayout xmlns:a="http://schemas.openxmlformats.org/drawingml/2006/main" xmlns:r="http://schemas.openxmlformats.org/officeDocument/2006/relationships" xmlns:p="http://schemas.openxmlformats.org/presentationml/2006/main" preserve="1" userDrawn="1">
+  <p:cSld name="Mentale gezondheid 3">
+    <p:spTree>
+      <p:nvGrpSpPr>
+        <p:cNvPr id="1" name=""/>
+        <p:cNvGrpSpPr/>
+        <p:nvPr/>
+      </p:nvGrpSpPr>
+      <p:grpSpPr>
+        <a:xfrm>
+          <a:off x="0" y="0"/>
+          <a:ext cx="0" cy="0"/>
+          <a:chOff x="0" y="0"/>
+          <a:chExt cx="0" cy="0"/>
+        </a:xfrm>
+      </p:grpSpPr>
+      <p:sp>
+        <p:nvSpPr>
+          <p:cNvPr id="7" name="Titelblok">
+            <a:extLst>
+              <a:ext uri="{FF2B5EF4-FFF2-40B4-BE49-F238E27FC236}">
+                <a16:creationId xmlns:a16="http://schemas.microsoft.com/office/drawing/2014/main" id="{A53C9265-3CEF-A2C1-7746-C8CDC77B0852}"/>
+              </a:ext>
+            </a:extLst>
+          </p:cNvPr>
+          <p:cNvSpPr/>
+          <p:nvPr userDrawn="1"/>
+        </p:nvSpPr>
+        <p:spPr>
+          <a:xfrm>
+            <a:off x="0" y="0"/>
+            <a:ext cx="10295595" cy="1066801"/>
+          </a:xfrm>
+          <a:custGeom>
+            <a:avLst/>
+            <a:gdLst>
+              <a:gd name="connsiteX0" fmla="*/ 0 w 10295595"/>
+              <a:gd name="connsiteY0" fmla="*/ 0 h 1066800"/>
+              <a:gd name="connsiteX1" fmla="*/ 10295595 w 10295595"/>
+              <a:gd name="connsiteY1" fmla="*/ 0 h 1066800"/>
+              <a:gd name="connsiteX2" fmla="*/ 10295595 w 10295595"/>
+              <a:gd name="connsiteY2" fmla="*/ 1066800 h 1066800"/>
+              <a:gd name="connsiteX3" fmla="*/ 0 w 10295595"/>
+              <a:gd name="connsiteY3" fmla="*/ 1066800 h 1066800"/>
+              <a:gd name="connsiteX4" fmla="*/ 0 w 10295595"/>
+              <a:gd name="connsiteY4" fmla="*/ 0 h 1066800"/>
+              <a:gd name="connsiteX0" fmla="*/ 0 w 10295595"/>
+              <a:gd name="connsiteY0" fmla="*/ 0 h 1066800"/>
+              <a:gd name="connsiteX1" fmla="*/ 10295595 w 10295595"/>
+              <a:gd name="connsiteY1" fmla="*/ 0 h 1066800"/>
+              <a:gd name="connsiteX2" fmla="*/ 9737543 w 10295595"/>
+              <a:gd name="connsiteY2" fmla="*/ 1066800 h 1066800"/>
+              <a:gd name="connsiteX3" fmla="*/ 0 w 10295595"/>
+              <a:gd name="connsiteY3" fmla="*/ 1066800 h 1066800"/>
+              <a:gd name="connsiteX4" fmla="*/ 0 w 10295595"/>
+              <a:gd name="connsiteY4" fmla="*/ 0 h 1066800"/>
+              <a:gd name="connsiteX0" fmla="*/ 0 w 10295595"/>
+              <a:gd name="connsiteY0" fmla="*/ 0 h 1066800"/>
+              <a:gd name="connsiteX1" fmla="*/ 10295595 w 10295595"/>
+              <a:gd name="connsiteY1" fmla="*/ 0 h 1066800"/>
+              <a:gd name="connsiteX2" fmla="*/ 9710649 w 10295595"/>
+              <a:gd name="connsiteY2" fmla="*/ 1060077 h 1066800"/>
+              <a:gd name="connsiteX3" fmla="*/ 0 w 10295595"/>
+              <a:gd name="connsiteY3" fmla="*/ 1066800 h 1066800"/>
+              <a:gd name="connsiteX4" fmla="*/ 0 w 10295595"/>
+              <a:gd name="connsiteY4" fmla="*/ 0 h 1066800"/>
+              <a:gd name="connsiteX0" fmla="*/ 0 w 10295595"/>
+              <a:gd name="connsiteY0" fmla="*/ 0 h 1066801"/>
+              <a:gd name="connsiteX1" fmla="*/ 10295595 w 10295595"/>
+              <a:gd name="connsiteY1" fmla="*/ 0 h 1066801"/>
+              <a:gd name="connsiteX2" fmla="*/ 9710649 w 10295595"/>
+              <a:gd name="connsiteY2" fmla="*/ 1066801 h 1066801"/>
+              <a:gd name="connsiteX3" fmla="*/ 0 w 10295595"/>
+              <a:gd name="connsiteY3" fmla="*/ 1066800 h 1066801"/>
+              <a:gd name="connsiteX4" fmla="*/ 0 w 10295595"/>
+              <a:gd name="connsiteY4" fmla="*/ 0 h 1066801"/>
+            </a:gdLst>
+            <a:ahLst/>
+            <a:cxnLst>
+              <a:cxn ang="0">
+                <a:pos x="connsiteX0" y="connsiteY0"/>
+              </a:cxn>
+              <a:cxn ang="0">
+                <a:pos x="connsiteX1" y="connsiteY1"/>
+              </a:cxn>
+              <a:cxn ang="0">
+                <a:pos x="connsiteX2" y="connsiteY2"/>
+              </a:cxn>
+              <a:cxn ang="0">
+                <a:pos x="connsiteX3" y="connsiteY3"/>
+              </a:cxn>
+              <a:cxn ang="0">
+                <a:pos x="connsiteX4" y="connsiteY4"/>
+              </a:cxn>
+            </a:cxnLst>
+            <a:rect l="l" t="t" r="r" b="b"/>
+            <a:pathLst>
+              <a:path w="10295595" h="1066801">
+                <a:moveTo>
+                  <a:pt x="0" y="0"/>
+                </a:moveTo>
+                <a:lnTo>
+                  <a:pt x="10295595" y="0"/>
+                </a:lnTo>
+                <a:lnTo>
+                  <a:pt x="9710649" y="1066801"/>
+                </a:lnTo>
+                <a:lnTo>
+                  <a:pt x="0" y="1066800"/>
+                </a:lnTo>
+                <a:lnTo>
+                  <a:pt x="0" y="0"/>
+                </a:lnTo>
+                <a:close/>
+              </a:path>
+            </a:pathLst>
+          </a:custGeom>
+          <a:solidFill>
+            <a:schemeClr val="accent3"/>
+          </a:solidFill>
+          <a:ln>
+            <a:noFill/>
+          </a:ln>
+        </p:spPr>
+        <p:style>
+          <a:lnRef idx="2">
+            <a:schemeClr val="accent1">
+              <a:shade val="50000"/>
+            </a:schemeClr>
+          </a:lnRef>
+          <a:fillRef idx="1">
+            <a:schemeClr val="accent1"/>
+          </a:fillRef>
+          <a:effectRef idx="0">
+            <a:schemeClr val="accent1"/>
+          </a:effectRef>
+          <a:fontRef idx="minor">
+            <a:schemeClr val="lt1"/>
+          </a:fontRef>
+        </p:style>
+        <p:txBody>
+          <a:bodyPr rtlCol="0" anchor="ctr"/>
+          <a:lstStyle/>
+          <a:p>
+            <a:pPr marL="0" indent="270272" algn="l"/>
+            <a:r>
+              <a:rPr lang="nl-NL" sz="2400" b="1" noProof="0" dirty="0">
+                <a:latin typeface="Century Gothic" panose="020B0502020202020204" pitchFamily="34" charset="0"/>
+              </a:rPr>
+              <a:t>Mentale gezondheid</a:t>
+            </a:r>
+            <a:endParaRPr lang="nl-NL" sz="1800" b="1" noProof="0" dirty="0">
+              <a:latin typeface="Century Gothic" panose="020B0502020202020204" pitchFamily="34" charset="0"/>
+            </a:endParaRPr>
+          </a:p>
+        </p:txBody>
+      </p:sp>
+      <p:sp>
+        <p:nvSpPr>
+          <p:cNvPr id="3" name="Grafiek">
+            <a:extLst>
+              <a:ext uri="{FF2B5EF4-FFF2-40B4-BE49-F238E27FC236}">
+                <a16:creationId xmlns:a16="http://schemas.microsoft.com/office/drawing/2014/main" id="{5F193AA4-09A3-CB31-87EE-2F190A925E48}"/>
+              </a:ext>
+            </a:extLst>
+          </p:cNvPr>
+          <p:cNvSpPr>
+            <a:spLocks noGrp="1"/>
+          </p:cNvSpPr>
+          <p:nvPr>
+            <p:ph type="chart" sz="quarter" idx="14"/>
+          </p:nvPr>
+        </p:nvSpPr>
+        <p:spPr>
+          <a:xfrm>
+            <a:off x="4074457" y="1983441"/>
+            <a:ext cx="5082989" cy="3193677"/>
+          </a:xfrm>
+          <a:prstGeom prst="rect">
+            <a:avLst/>
+          </a:prstGeom>
+        </p:spPr>
+        <p:txBody>
+          <a:bodyPr/>
+          <a:lstStyle>
+            <a:lvl1pPr marL="0" indent="0">
+              <a:buNone/>
+              <a:defRPr/>
+            </a:lvl1pPr>
+          </a:lstStyle>
+          <a:p>
+            <a:endParaRPr lang="nl-NL" dirty="0"/>
+          </a:p>
+        </p:txBody>
+      </p:sp>
+    </p:spTree>
+    <p:extLst>
+      <p:ext uri="{BB962C8B-B14F-4D97-AF65-F5344CB8AC3E}">
+        <p14:creationId xmlns:p14="http://schemas.microsoft.com/office/powerpoint/2010/main" val="3674646998"/>
+      </p:ext>
+    </p:extLst>
+  </p:cSld>
+  <p:clrMapOvr>
+    <a:masterClrMapping/>
+  </p:clrMapOvr>
+</p:sldLayout>
+</file>
+
+<file path=ppt/slideLayouts/slideLayout8.xml><?xml version="1.0" encoding="utf-8"?>
+<p:sldLayout xmlns:a="http://schemas.openxmlformats.org/drawingml/2006/main" xmlns:r="http://schemas.openxmlformats.org/officeDocument/2006/relationships" xmlns:p="http://schemas.openxmlformats.org/presentationml/2006/main" preserve="1" userDrawn="1">
   <p:cSld name="Gezin">
     <p:spTree>
       <p:nvGrpSpPr>
@@ -5284,7 +5580,7 @@
 </p:sldLayout>
 </file>
 
-<file path=ppt/slideLayouts/slideLayout8.xml><?xml version="1.0" encoding="utf-8"?>
+<file path=ppt/slideLayouts/slideLayout9.xml><?xml version="1.0" encoding="utf-8"?>
 <p:sldLayout xmlns:a="http://schemas.openxmlformats.org/drawingml/2006/main" xmlns:r="http://schemas.openxmlformats.org/officeDocument/2006/relationships" xmlns:p="http://schemas.openxmlformats.org/presentationml/2006/main" preserve="1" userDrawn="1">
   <p:cSld name="Gezin 2">
     <p:spTree>
@@ -5529,373 +5825,6 @@
 </p:sldLayout>
 </file>
 
-<file path=ppt/slideLayouts/slideLayout9.xml><?xml version="1.0" encoding="utf-8"?>
-<p:sldLayout xmlns:a="http://schemas.openxmlformats.org/drawingml/2006/main" xmlns:r="http://schemas.openxmlformats.org/officeDocument/2006/relationships" xmlns:p="http://schemas.openxmlformats.org/presentationml/2006/main" preserve="1" userDrawn="1">
-  <p:cSld name="School">
-    <p:spTree>
-      <p:nvGrpSpPr>
-        <p:cNvPr id="1" name=""/>
-        <p:cNvGrpSpPr/>
-        <p:nvPr/>
-      </p:nvGrpSpPr>
-      <p:grpSpPr>
-        <a:xfrm>
-          <a:off x="0" y="0"/>
-          <a:ext cx="0" cy="0"/>
-          <a:chOff x="0" y="0"/>
-          <a:chExt cx="0" cy="0"/>
-        </a:xfrm>
-      </p:grpSpPr>
-      <p:sp>
-        <p:nvSpPr>
-          <p:cNvPr id="7" name="Titelblok">
-            <a:extLst>
-              <a:ext uri="{FF2B5EF4-FFF2-40B4-BE49-F238E27FC236}">
-                <a16:creationId xmlns:a16="http://schemas.microsoft.com/office/drawing/2014/main" id="{A53C9265-3CEF-A2C1-7746-C8CDC77B0852}"/>
-              </a:ext>
-            </a:extLst>
-          </p:cNvPr>
-          <p:cNvSpPr/>
-          <p:nvPr userDrawn="1"/>
-        </p:nvSpPr>
-        <p:spPr>
-          <a:xfrm>
-            <a:off x="0" y="0"/>
-            <a:ext cx="10295595" cy="1066801"/>
-          </a:xfrm>
-          <a:custGeom>
-            <a:avLst/>
-            <a:gdLst>
-              <a:gd name="connsiteX0" fmla="*/ 0 w 10295595"/>
-              <a:gd name="connsiteY0" fmla="*/ 0 h 1066800"/>
-              <a:gd name="connsiteX1" fmla="*/ 10295595 w 10295595"/>
-              <a:gd name="connsiteY1" fmla="*/ 0 h 1066800"/>
-              <a:gd name="connsiteX2" fmla="*/ 10295595 w 10295595"/>
-              <a:gd name="connsiteY2" fmla="*/ 1066800 h 1066800"/>
-              <a:gd name="connsiteX3" fmla="*/ 0 w 10295595"/>
-              <a:gd name="connsiteY3" fmla="*/ 1066800 h 1066800"/>
-              <a:gd name="connsiteX4" fmla="*/ 0 w 10295595"/>
-              <a:gd name="connsiteY4" fmla="*/ 0 h 1066800"/>
-              <a:gd name="connsiteX0" fmla="*/ 0 w 10295595"/>
-              <a:gd name="connsiteY0" fmla="*/ 0 h 1066800"/>
-              <a:gd name="connsiteX1" fmla="*/ 10295595 w 10295595"/>
-              <a:gd name="connsiteY1" fmla="*/ 0 h 1066800"/>
-              <a:gd name="connsiteX2" fmla="*/ 9737543 w 10295595"/>
-              <a:gd name="connsiteY2" fmla="*/ 1066800 h 1066800"/>
-              <a:gd name="connsiteX3" fmla="*/ 0 w 10295595"/>
-              <a:gd name="connsiteY3" fmla="*/ 1066800 h 1066800"/>
-              <a:gd name="connsiteX4" fmla="*/ 0 w 10295595"/>
-              <a:gd name="connsiteY4" fmla="*/ 0 h 1066800"/>
-              <a:gd name="connsiteX0" fmla="*/ 0 w 10295595"/>
-              <a:gd name="connsiteY0" fmla="*/ 0 h 1066800"/>
-              <a:gd name="connsiteX1" fmla="*/ 10295595 w 10295595"/>
-              <a:gd name="connsiteY1" fmla="*/ 0 h 1066800"/>
-              <a:gd name="connsiteX2" fmla="*/ 9710649 w 10295595"/>
-              <a:gd name="connsiteY2" fmla="*/ 1060077 h 1066800"/>
-              <a:gd name="connsiteX3" fmla="*/ 0 w 10295595"/>
-              <a:gd name="connsiteY3" fmla="*/ 1066800 h 1066800"/>
-              <a:gd name="connsiteX4" fmla="*/ 0 w 10295595"/>
-              <a:gd name="connsiteY4" fmla="*/ 0 h 1066800"/>
-              <a:gd name="connsiteX0" fmla="*/ 0 w 10295595"/>
-              <a:gd name="connsiteY0" fmla="*/ 0 h 1066801"/>
-              <a:gd name="connsiteX1" fmla="*/ 10295595 w 10295595"/>
-              <a:gd name="connsiteY1" fmla="*/ 0 h 1066801"/>
-              <a:gd name="connsiteX2" fmla="*/ 9710649 w 10295595"/>
-              <a:gd name="connsiteY2" fmla="*/ 1066801 h 1066801"/>
-              <a:gd name="connsiteX3" fmla="*/ 0 w 10295595"/>
-              <a:gd name="connsiteY3" fmla="*/ 1066800 h 1066801"/>
-              <a:gd name="connsiteX4" fmla="*/ 0 w 10295595"/>
-              <a:gd name="connsiteY4" fmla="*/ 0 h 1066801"/>
-            </a:gdLst>
-            <a:ahLst/>
-            <a:cxnLst>
-              <a:cxn ang="0">
-                <a:pos x="connsiteX0" y="connsiteY0"/>
-              </a:cxn>
-              <a:cxn ang="0">
-                <a:pos x="connsiteX1" y="connsiteY1"/>
-              </a:cxn>
-              <a:cxn ang="0">
-                <a:pos x="connsiteX2" y="connsiteY2"/>
-              </a:cxn>
-              <a:cxn ang="0">
-                <a:pos x="connsiteX3" y="connsiteY3"/>
-              </a:cxn>
-              <a:cxn ang="0">
-                <a:pos x="connsiteX4" y="connsiteY4"/>
-              </a:cxn>
-            </a:cxnLst>
-            <a:rect l="l" t="t" r="r" b="b"/>
-            <a:pathLst>
-              <a:path w="10295595" h="1066801">
-                <a:moveTo>
-                  <a:pt x="0" y="0"/>
-                </a:moveTo>
-                <a:lnTo>
-                  <a:pt x="10295595" y="0"/>
-                </a:lnTo>
-                <a:lnTo>
-                  <a:pt x="9710649" y="1066801"/>
-                </a:lnTo>
-                <a:lnTo>
-                  <a:pt x="0" y="1066800"/>
-                </a:lnTo>
-                <a:lnTo>
-                  <a:pt x="0" y="0"/>
-                </a:lnTo>
-                <a:close/>
-              </a:path>
-            </a:pathLst>
-          </a:custGeom>
-          <a:solidFill>
-            <a:schemeClr val="accent4"/>
-          </a:solidFill>
-          <a:ln>
-            <a:noFill/>
-          </a:ln>
-        </p:spPr>
-        <p:style>
-          <a:lnRef idx="0">
-            <a:scrgbClr r="0" g="0" b="0"/>
-          </a:lnRef>
-          <a:fillRef idx="0">
-            <a:scrgbClr r="0" g="0" b="0"/>
-          </a:fillRef>
-          <a:effectRef idx="0">
-            <a:scrgbClr r="0" g="0" b="0"/>
-          </a:effectRef>
-          <a:fontRef idx="minor">
-            <a:schemeClr val="lt1"/>
-          </a:fontRef>
-        </p:style>
-        <p:txBody>
-          <a:bodyPr rtlCol="0" anchor="ctr"/>
-          <a:lstStyle/>
-          <a:p>
-            <a:pPr marL="0" indent="270272" algn="l"/>
-            <a:r>
-              <a:rPr lang="nl-NL" sz="2400" b="1" noProof="0" dirty="0">
-                <a:latin typeface="Century Gothic" panose="020B0502020202020204" pitchFamily="34" charset="0"/>
-              </a:rPr>
-              <a:t>School</a:t>
-            </a:r>
-            <a:endParaRPr lang="nl-NL" sz="1800" b="1" noProof="0" dirty="0">
-              <a:latin typeface="Century Gothic" panose="020B0502020202020204" pitchFamily="34" charset="0"/>
-            </a:endParaRPr>
-          </a:p>
-        </p:txBody>
-      </p:sp>
-      <p:cxnSp>
-        <p:nvCxnSpPr>
-          <p:cNvPr id="3" name="Rechte verbindingslijn 1">
-            <a:extLst>
-              <a:ext uri="{FF2B5EF4-FFF2-40B4-BE49-F238E27FC236}">
-                <a16:creationId xmlns:a16="http://schemas.microsoft.com/office/drawing/2014/main" id="{9AF48131-3415-6F18-82EA-A7896B2FF722}"/>
-              </a:ext>
-            </a:extLst>
-          </p:cNvPr>
-          <p:cNvCxnSpPr>
-            <a:cxnSpLocks/>
-          </p:cNvCxnSpPr>
-          <p:nvPr userDrawn="1"/>
-        </p:nvCxnSpPr>
-        <p:spPr>
-          <a:xfrm flipV="1">
-            <a:off x="4140175" y="1519200"/>
-            <a:ext cx="0" cy="4881600"/>
-          </a:xfrm>
-          <a:prstGeom prst="line">
-            <a:avLst/>
-          </a:prstGeom>
-          <a:ln w="12700">
-            <a:solidFill>
-              <a:schemeClr val="tx2">
-                <a:lumMod val="20000"/>
-                <a:lumOff val="80000"/>
-              </a:schemeClr>
-            </a:solidFill>
-          </a:ln>
-        </p:spPr>
-        <p:style>
-          <a:lnRef idx="1">
-            <a:schemeClr val="accent1"/>
-          </a:lnRef>
-          <a:fillRef idx="0">
-            <a:schemeClr val="accent1"/>
-          </a:fillRef>
-          <a:effectRef idx="0">
-            <a:schemeClr val="accent1"/>
-          </a:effectRef>
-          <a:fontRef idx="minor">
-            <a:schemeClr val="tx1"/>
-          </a:fontRef>
-        </p:style>
-      </p:cxnSp>
-      <p:sp>
-        <p:nvSpPr>
-          <p:cNvPr id="4" name="Grafiek 4">
-            <a:extLst>
-              <a:ext uri="{FF2B5EF4-FFF2-40B4-BE49-F238E27FC236}">
-                <a16:creationId xmlns:a16="http://schemas.microsoft.com/office/drawing/2014/main" id="{310E4352-31FF-44EB-5021-279E162058B9}"/>
-              </a:ext>
-            </a:extLst>
-          </p:cNvPr>
-          <p:cNvSpPr>
-            <a:spLocks noGrp="1"/>
-          </p:cNvSpPr>
-          <p:nvPr>
-            <p:ph type="chart" sz="quarter" idx="21"/>
-          </p:nvPr>
-        </p:nvSpPr>
-        <p:spPr>
-          <a:xfrm>
-            <a:off x="4366163" y="4204800"/>
-            <a:ext cx="5400000" cy="2160000"/>
-          </a:xfrm>
-          <a:prstGeom prst="rect">
-            <a:avLst/>
-          </a:prstGeom>
-        </p:spPr>
-        <p:txBody>
-          <a:bodyPr/>
-          <a:lstStyle>
-            <a:lvl1pPr marL="0" indent="0">
-              <a:buNone/>
-              <a:defRPr sz="3200"/>
-            </a:lvl1pPr>
-          </a:lstStyle>
-          <a:p>
-            <a:endParaRPr lang="nl-NL" dirty="0"/>
-          </a:p>
-        </p:txBody>
-      </p:sp>
-      <p:sp>
-        <p:nvSpPr>
-          <p:cNvPr id="5" name="Grafiek 3">
-            <a:extLst>
-              <a:ext uri="{FF2B5EF4-FFF2-40B4-BE49-F238E27FC236}">
-                <a16:creationId xmlns:a16="http://schemas.microsoft.com/office/drawing/2014/main" id="{549FA444-6519-F015-40E7-530F58844B81}"/>
-              </a:ext>
-            </a:extLst>
-          </p:cNvPr>
-          <p:cNvSpPr>
-            <a:spLocks noGrp="1"/>
-          </p:cNvSpPr>
-          <p:nvPr>
-            <p:ph type="chart" sz="quarter" idx="17"/>
-          </p:nvPr>
-        </p:nvSpPr>
-        <p:spPr>
-          <a:xfrm>
-            <a:off x="4366161" y="1519199"/>
-            <a:ext cx="5400000" cy="2160000"/>
-          </a:xfrm>
-          <a:prstGeom prst="rect">
-            <a:avLst/>
-          </a:prstGeom>
-        </p:spPr>
-        <p:txBody>
-          <a:bodyPr/>
-          <a:lstStyle>
-            <a:lvl1pPr marL="0" indent="0">
-              <a:buNone/>
-              <a:defRPr sz="3200"/>
-            </a:lvl1pPr>
-          </a:lstStyle>
-          <a:p>
-            <a:endParaRPr lang="nl-NL"/>
-          </a:p>
-        </p:txBody>
-      </p:sp>
-      <p:sp>
-        <p:nvSpPr>
-          <p:cNvPr id="6" name="Grafiek 2">
-            <a:extLst>
-              <a:ext uri="{FF2B5EF4-FFF2-40B4-BE49-F238E27FC236}">
-                <a16:creationId xmlns:a16="http://schemas.microsoft.com/office/drawing/2014/main" id="{F67D3483-9559-7D5C-8A22-30732942E8F9}"/>
-              </a:ext>
-            </a:extLst>
-          </p:cNvPr>
-          <p:cNvSpPr>
-            <a:spLocks noGrp="1"/>
-          </p:cNvSpPr>
-          <p:nvPr>
-            <p:ph type="chart" sz="quarter" idx="22"/>
-          </p:nvPr>
-        </p:nvSpPr>
-        <p:spPr>
-          <a:xfrm>
-            <a:off x="454514" y="4204800"/>
-            <a:ext cx="3456000" cy="2160000"/>
-          </a:xfrm>
-          <a:prstGeom prst="rect">
-            <a:avLst/>
-          </a:prstGeom>
-        </p:spPr>
-        <p:txBody>
-          <a:bodyPr/>
-          <a:lstStyle>
-            <a:lvl1pPr marL="0" indent="0">
-              <a:buNone/>
-              <a:defRPr sz="3200"/>
-            </a:lvl1pPr>
-          </a:lstStyle>
-          <a:p>
-            <a:endParaRPr lang="nl-NL" dirty="0"/>
-          </a:p>
-        </p:txBody>
-      </p:sp>
-      <p:sp>
-        <p:nvSpPr>
-          <p:cNvPr id="8" name="Grafiek 1">
-            <a:extLst>
-              <a:ext uri="{FF2B5EF4-FFF2-40B4-BE49-F238E27FC236}">
-                <a16:creationId xmlns:a16="http://schemas.microsoft.com/office/drawing/2014/main" id="{970EE836-F25C-DF4F-5C39-4E6A87FBE76D}"/>
-              </a:ext>
-            </a:extLst>
-          </p:cNvPr>
-          <p:cNvSpPr>
-            <a:spLocks noGrp="1"/>
-          </p:cNvSpPr>
-          <p:nvPr>
-            <p:ph type="chart" sz="quarter" idx="23"/>
-          </p:nvPr>
-        </p:nvSpPr>
-        <p:spPr>
-          <a:xfrm>
-            <a:off x="454514" y="1519199"/>
-            <a:ext cx="3456000" cy="2160000"/>
-          </a:xfrm>
-          <a:prstGeom prst="rect">
-            <a:avLst/>
-          </a:prstGeom>
-        </p:spPr>
-        <p:txBody>
-          <a:bodyPr/>
-          <a:lstStyle>
-            <a:lvl1pPr marL="0" indent="0">
-              <a:buNone/>
-              <a:defRPr sz="3200"/>
-            </a:lvl1pPr>
-          </a:lstStyle>
-          <a:p>
-            <a:endParaRPr lang="nl-NL" dirty="0"/>
-          </a:p>
-        </p:txBody>
-      </p:sp>
-    </p:spTree>
-    <p:extLst>
-      <p:ext uri="{BB962C8B-B14F-4D97-AF65-F5344CB8AC3E}">
-        <p14:creationId xmlns:p14="http://schemas.microsoft.com/office/powerpoint/2010/main" val="830588291"/>
-      </p:ext>
-    </p:extLst>
-  </p:cSld>
-  <p:clrMapOvr>
-    <a:masterClrMapping/>
-  </p:clrMapOvr>
-</p:sldLayout>
-</file>
-
 <file path=ppt/slideMasters/slideMaster1.xml><?xml version="1.0" encoding="utf-8"?>
 <p:sldMaster xmlns:a="http://schemas.openxmlformats.org/drawingml/2006/main" xmlns:r="http://schemas.openxmlformats.org/officeDocument/2006/relationships" xmlns:p="http://schemas.openxmlformats.org/presentationml/2006/main" preserve="1">
   <p:cSld>
@@ -5933,7 +5862,7 @@
           <p:nvPr userDrawn="1"/>
         </p:nvPicPr>
         <p:blipFill>
-          <a:blip r:embed="rId16">
+          <a:blip r:embed="rId17">
             <a:extLst>
               <a:ext uri="{28A0092B-C50C-407E-A947-70E740481C1C}">
                 <a14:useLocalDpi xmlns:a14="http://schemas.microsoft.com/office/drawing/2010/main" val="0"/>
@@ -5970,14 +5899,15 @@
     <p:sldLayoutId id="2147483720" r:id="rId4"/>
     <p:sldLayoutId id="2147483715" r:id="rId5"/>
     <p:sldLayoutId id="2147483722" r:id="rId6"/>
-    <p:sldLayoutId id="2147483716" r:id="rId7"/>
-    <p:sldLayoutId id="2147483721" r:id="rId8"/>
-    <p:sldLayoutId id="2147483717" r:id="rId9"/>
-    <p:sldLayoutId id="2147483723" r:id="rId10"/>
-    <p:sldLayoutId id="2147483718" r:id="rId11"/>
-    <p:sldLayoutId id="2147483724" r:id="rId12"/>
-    <p:sldLayoutId id="2147483719" r:id="rId13"/>
-    <p:sldLayoutId id="2147483725" r:id="rId14"/>
+    <p:sldLayoutId id="2147483726" r:id="rId7"/>
+    <p:sldLayoutId id="2147483716" r:id="rId8"/>
+    <p:sldLayoutId id="2147483721" r:id="rId9"/>
+    <p:sldLayoutId id="2147483717" r:id="rId10"/>
+    <p:sldLayoutId id="2147483723" r:id="rId11"/>
+    <p:sldLayoutId id="2147483718" r:id="rId12"/>
+    <p:sldLayoutId id="2147483724" r:id="rId13"/>
+    <p:sldLayoutId id="2147483719" r:id="rId14"/>
+    <p:sldLayoutId id="2147483725" r:id="rId15"/>
   </p:sldLayoutIdLst>
   <p:txStyles>
     <p:titleStyle>
@@ -7081,33 +7011,8 @@
 </file>
 
 <file path=customXml/item1.xml><?xml version="1.0" encoding="utf-8"?>
-<?mso-contentType ?>
-<FormTemplates xmlns="http://schemas.microsoft.com/sharepoint/v3/contenttype/forms">
-  <Display>DocumentLibraryForm</Display>
-  <Edit>DocumentLibraryForm</Edit>
-  <New>DocumentLibraryForm</New>
-</FormTemplates>
-</file>
-
-<file path=customXml/item2.xml><?xml version="1.0" encoding="utf-8"?>
-<p:properties xmlns:p="http://schemas.microsoft.com/office/2006/metadata/properties" xmlns:xsi="http://www.w3.org/2001/XMLSchema-instance" xmlns:pc="http://schemas.microsoft.com/office/infopath/2007/PartnerControls">
-  <documentManagement>
-    <_ip_UnifiedCompliancePolicyUIAction xmlns="http://schemas.microsoft.com/sharepoint/v3" xsi:nil="true"/>
-    <lcf76f155ced4ddcb4097134ff3c332f xmlns="4e95bed8-6d15-4403-ad70-a53422338dca">
-      <Terms xmlns="http://schemas.microsoft.com/office/infopath/2007/PartnerControls"/>
-    </lcf76f155ced4ddcb4097134ff3c332f>
-    <_ip_UnifiedCompliancePolicyProperties xmlns="http://schemas.microsoft.com/sharepoint/v3" xsi:nil="true"/>
-    <TaxCatchAll xmlns="d045ab76-3bb7-45f5-ab41-d7b04aa0dc94" xsi:nil="true"/>
-    <TaxKeywordTaxHTField xmlns="d045ab76-3bb7-45f5-ab41-d7b04aa0dc94">
-      <Terms xmlns="http://schemas.microsoft.com/office/infopath/2007/PartnerControls"/>
-    </TaxKeywordTaxHTField>
-  </documentManagement>
-</p:properties>
-</file>
-
-<file path=customXml/item3.xml><?xml version="1.0" encoding="utf-8"?>
-<ct:contentTypeSchema xmlns:ct="http://schemas.microsoft.com/office/2006/metadata/contentType" xmlns:ma="http://schemas.microsoft.com/office/2006/metadata/properties/metaAttributes" ct:_="" ma:_="" ma:contentTypeName="Document" ma:contentTypeID="0x010100C4EA295FB1FB9547A73C9F5819D6E613" ma:contentTypeVersion="22" ma:contentTypeDescription="Een nieuw document maken." ma:contentTypeScope="" ma:versionID="e49181b65574406c5282aee675d2d615">
-  <xsd:schema xmlns:xsd="http://www.w3.org/2001/XMLSchema" xmlns:xs="http://www.w3.org/2001/XMLSchema" xmlns:p="http://schemas.microsoft.com/office/2006/metadata/properties" xmlns:ns1="http://schemas.microsoft.com/sharepoint/v3" xmlns:ns2="4e95bed8-6d15-4403-ad70-a53422338dca" xmlns:ns3="10d3344f-2d16-43d9-a145-97142f5cb288" xmlns:ns4="d045ab76-3bb7-45f5-ab41-d7b04aa0dc94" targetNamespace="http://schemas.microsoft.com/office/2006/metadata/properties" ma:root="true" ma:fieldsID="cc6d884b6a76c93e77d17ea8b02330de" ns1:_="" ns2:_="" ns3:_="" ns4:_="">
+<ct:contentTypeSchema xmlns:ct="http://schemas.microsoft.com/office/2006/metadata/contentType" xmlns:ma="http://schemas.microsoft.com/office/2006/metadata/properties/metaAttributes" ct:_="" ma:_="" ma:contentTypeName="Document" ma:contentTypeID="0x010100C4EA295FB1FB9547A73C9F5819D6E613" ma:contentTypeVersion="22" ma:contentTypeDescription="Een nieuw document maken." ma:contentTypeScope="" ma:versionID="586e6f9b10cb27d3f03483507ae7cb9d">
+  <xsd:schema xmlns:xsd="http://www.w3.org/2001/XMLSchema" xmlns:xs="http://www.w3.org/2001/XMLSchema" xmlns:p="http://schemas.microsoft.com/office/2006/metadata/properties" xmlns:ns1="http://schemas.microsoft.com/sharepoint/v3" xmlns:ns2="4e95bed8-6d15-4403-ad70-a53422338dca" xmlns:ns3="10d3344f-2d16-43d9-a145-97142f5cb288" xmlns:ns4="d045ab76-3bb7-45f5-ab41-d7b04aa0dc94" targetNamespace="http://schemas.microsoft.com/office/2006/metadata/properties" ma:root="true" ma:fieldsID="f29125cba2118f3064d103e6e0ba85ce" ns1:_="" ns2:_="" ns3:_="" ns4:_="">
     <xsd:import namespace="http://schemas.microsoft.com/sharepoint/v3"/>
     <xsd:import namespace="4e95bed8-6d15-4403-ad70-a53422338dca"/>
     <xsd:import namespace="10d3344f-2d16-43d9-a145-97142f5cb288"/>
@@ -7390,12 +7295,33 @@
 </ct:contentTypeSchema>
 </file>
 
+<file path=customXml/item2.xml><?xml version="1.0" encoding="utf-8"?>
+<p:properties xmlns:p="http://schemas.microsoft.com/office/2006/metadata/properties" xmlns:xsi="http://www.w3.org/2001/XMLSchema-instance" xmlns:pc="http://schemas.microsoft.com/office/infopath/2007/PartnerControls">
+  <documentManagement>
+    <_ip_UnifiedCompliancePolicyUIAction xmlns="http://schemas.microsoft.com/sharepoint/v3" xsi:nil="true"/>
+    <lcf76f155ced4ddcb4097134ff3c332f xmlns="4e95bed8-6d15-4403-ad70-a53422338dca">
+      <Terms xmlns="http://schemas.microsoft.com/office/infopath/2007/PartnerControls"/>
+    </lcf76f155ced4ddcb4097134ff3c332f>
+    <_ip_UnifiedCompliancePolicyProperties xmlns="http://schemas.microsoft.com/sharepoint/v3" xsi:nil="true"/>
+    <TaxCatchAll xmlns="d045ab76-3bb7-45f5-ab41-d7b04aa0dc94" xsi:nil="true"/>
+    <TaxKeywordTaxHTField xmlns="d045ab76-3bb7-45f5-ab41-d7b04aa0dc94">
+      <Terms xmlns="http://schemas.microsoft.com/office/infopath/2007/PartnerControls"/>
+    </TaxKeywordTaxHTField>
+  </documentManagement>
+</p:properties>
+</file>
+
+<file path=customXml/item3.xml><?xml version="1.0" encoding="utf-8"?>
+<?mso-contentType ?>
+<FormTemplates xmlns="http://schemas.microsoft.com/sharepoint/v3/contenttype/forms">
+  <Display>DocumentLibraryForm</Display>
+  <Edit>DocumentLibraryForm</Edit>
+  <New>DocumentLibraryForm</New>
+</FormTemplates>
+</file>
+
 <file path=customXml/itemProps1.xml><?xml version="1.0" encoding="utf-8"?>
-<ds:datastoreItem xmlns:ds="http://schemas.openxmlformats.org/officeDocument/2006/customXml" ds:itemID="{D4797234-1F06-4080-A1F9-30DCE4CF2F06}">
-  <ds:schemaRefs>
-    <ds:schemaRef ds:uri="http://schemas.microsoft.com/sharepoint/v3/contenttype/forms"/>
-  </ds:schemaRefs>
-</ds:datastoreItem>
+<ds:datastoreItem xmlns:ds="http://schemas.openxmlformats.org/officeDocument/2006/customXml" ds:itemID="{1BBE5193-1145-40F4-8BD8-A14B99FDAA13}"/>
 </file>
 
 <file path=customXml/itemProps2.xml><?xml version="1.0" encoding="utf-8"?>
@@ -7418,22 +7344,9 @@
 </file>
 
 <file path=customXml/itemProps3.xml><?xml version="1.0" encoding="utf-8"?>
-<ds:datastoreItem xmlns:ds="http://schemas.openxmlformats.org/officeDocument/2006/customXml" ds:itemID="{4F1CF73A-4EA0-4141-87E3-9F6DA2499A43}">
+<ds:datastoreItem xmlns:ds="http://schemas.openxmlformats.org/officeDocument/2006/customXml" ds:itemID="{D4797234-1F06-4080-A1F9-30DCE4CF2F06}">
   <ds:schemaRefs>
-    <ds:schemaRef ds:uri="http://schemas.microsoft.com/office/2006/metadata/contentType"/>
-    <ds:schemaRef ds:uri="http://schemas.microsoft.com/office/2006/metadata/properties/metaAttributes"/>
-    <ds:schemaRef ds:uri="http://www.w3.org/2001/XMLSchema"/>
-    <ds:schemaRef ds:uri="http://schemas.microsoft.com/office/2006/metadata/properties"/>
-    <ds:schemaRef ds:uri="http://schemas.microsoft.com/sharepoint/v3"/>
-    <ds:schemaRef ds:uri="4e95bed8-6d15-4403-ad70-a53422338dca"/>
-    <ds:schemaRef ds:uri="10d3344f-2d16-43d9-a145-97142f5cb288"/>
-    <ds:schemaRef ds:uri="d045ab76-3bb7-45f5-ab41-d7b04aa0dc94"/>
-    <ds:schemaRef ds:uri="http://schemas.microsoft.com/office/2006/documentManagement/types"/>
-    <ds:schemaRef ds:uri="http://schemas.microsoft.com/office/infopath/2007/PartnerControls"/>
-    <ds:schemaRef ds:uri="http://schemas.openxmlformats.org/package/2006/metadata/core-properties"/>
-    <ds:schemaRef ds:uri="http://purl.org/dc/elements/1.1/"/>
-    <ds:schemaRef ds:uri="http://purl.org/dc/terms/"/>
-    <ds:schemaRef ds:uri="http://schemas.microsoft.com/internal/obd"/>
+    <ds:schemaRef ds:uri="http://schemas.microsoft.com/sharepoint/v3/contenttype/forms"/>
   </ds:schemaRefs>
 </ds:datastoreItem>
 </file>
</xml_diff>